<commit_message>
docs: update presentation deck to high-resolution 8-slide PPTX with UI screenshots
</commit_message>
<xml_diff>
--- a/Harmony_Project_Deck_Architecture.pptx
+++ b/Harmony_Project_Deck_Architecture.pptx
@@ -10,6 +10,9 @@
     <p:sldId id="258" r:id="rId9"/>
     <p:sldId id="259" r:id="rId10"/>
     <p:sldId id="260" r:id="rId11"/>
+    <p:sldId id="261" r:id="rId12"/>
+    <p:sldId id="262" r:id="rId13"/>
+    <p:sldId id="263" r:id="rId14"/>
   </p:sldIdLst>
   <p:sldSz cx="12191695" cy="6858000" type="screen4x3"/>
   <p:notesSz cx="6858000" cy="9144000"/>
@@ -3108,8 +3111,8 @@
         </p:nvSpPr>
         <p:spPr>
           <a:xfrm>
-            <a:off x="914400" y="1645920"/>
-            <a:ext cx="10362895" cy="3657600"/>
+            <a:off x="914400" y="1371600"/>
+            <a:ext cx="10362895" cy="4114800"/>
           </a:xfrm>
           <a:prstGeom prst="rect">
             <a:avLst/>
@@ -3126,22 +3129,22 @@
               <a:spcAft>
                 <a:spcPts val="1400"/>
               </a:spcAft>
-              <a:defRPr sz="1600" b="1">
+              <a:defRPr sz="1500" b="1">
                 <a:solidFill>
                   <a:srgbClr val="60A5FA"/>
                 </a:solidFill>
               </a:defRPr>
             </a:pPr>
             <a:r>
-              <a:t>Google Cloud Gen AI Academy APAC 2026 — Ideathon Challenge</a:t>
+              <a:t>Google Cloud Gen AI Academy APAC 2026 — Ideathon Challenge (#AllThingsAgentic)</a:t>
             </a:r>
           </a:p>
           <a:p>
             <a:pPr>
               <a:spcAft>
-                <a:spcPts val="1400"/>
+                <a:spcPts val="1200"/>
               </a:spcAft>
-              <a:defRPr sz="3600" b="1">
+              <a:defRPr sz="3400" b="1">
                 <a:solidFill>
                   <a:srgbClr val="FFFFFF"/>
                 </a:solidFill>
@@ -3154,7 +3157,7 @@
           <a:p>
             <a:pPr>
               <a:spcAft>
-                <a:spcPts val="3000"/>
+                <a:spcPts val="2800"/>
               </a:spcAft>
               <a:defRPr sz="1800">
                 <a:solidFill>
@@ -3163,23 +3166,27 @@
               </a:defRPr>
             </a:pPr>
             <a:r>
-              <a:t>Production-Ready, Authenticated &amp; UID-Isolated AI Reflection &amp; Auditing Platform on Google Cloud Run</a:t>
+              <a:t>Reflect &amp; Audit with Harmony: An AI-Powered Personal Journal Auditing &amp; Reflection Platform</a:t>
             </a:r>
           </a:p>
           <a:p>
             <a:pPr>
-              <a:defRPr sz="1400">
+              <a:defRPr sz="1300">
                 <a:solidFill>
                   <a:srgbClr val="94A3B8"/>
                 </a:solidFill>
               </a:defRPr>
             </a:pPr>
             <a:r>
-              <a:t>Live Prototype: https://personal-gemini-journal-344135619629.asia-south1.run.app</a:t>
+              <a:t>• Live Prototype: https://personal-gemini-journal-344135619629.asia-south1.run.app</a:t>
             </a:r>
             <a:br/>
             <a:r>
-              <a:t>GitHub Repository: https://github.com/DevRanbir/personal-gemini-journal</a:t>
+              <a:t>• GitHub Repository: https://github.com/DevRanbir/personal-gemini-journal</a:t>
+            </a:r>
+            <a:br/>
+            <a:r>
+              <a:t>• Tech Stack: Next.js 16, Google Gemini API, Firebase Auth, Cloud Firestore, GCP Secret Manager, Cloud Run</a:t>
             </a:r>
           </a:p>
         </p:txBody>
@@ -3218,8 +3225,8 @@
         </p:nvSpPr>
         <p:spPr>
           <a:xfrm>
-            <a:off x="731520" y="457200"/>
-            <a:ext cx="10698480" cy="914400"/>
+            <a:off x="731520" y="365760"/>
+            <a:ext cx="10698480" cy="822960"/>
           </a:xfrm>
           <a:prstGeom prst="rect">
             <a:avLst/>
@@ -3227,13 +3234,25 @@
           <a:noFill/>
         </p:spPr>
         <p:txBody>
-          <a:bodyPr wrap="none">
+          <a:bodyPr wrap="square">
             <a:spAutoFit/>
           </a:bodyPr>
           <a:lstStyle/>
           <a:p>
             <a:pPr>
-              <a:defRPr sz="2400" b="1">
+              <a:defRPr sz="1100" b="1">
+                <a:solidFill>
+                  <a:srgbClr val="2563EB"/>
+                </a:solidFill>
+              </a:defRPr>
+            </a:pPr>
+            <a:r>
+              <a:t>HARMONY — PERSONAL JOURNAL AUDITING WEB APP</a:t>
+            </a:r>
+          </a:p>
+          <a:p>
+            <a:pPr>
+              <a:defRPr sz="2200" b="1">
                 <a:solidFill>
                   <a:srgbClr val="0F172A"/>
                 </a:solidFill>
@@ -3254,8 +3273,8 @@
           <p:nvPr/>
         </p:nvGraphicFramePr>
         <p:xfrm>
-          <a:off x="731520" y="1371600"/>
-          <a:ext cx="10728655" cy="4754880"/>
+          <a:off x="731520" y="1280160"/>
+          <a:ext cx="10728655" cy="4937760"/>
         </p:xfrm>
         <a:graphic>
           <a:graphicData uri="http://schemas.openxmlformats.org/drawingml/2006/table">
@@ -3264,11 +3283,11 @@
                 <a:tableStyleId>{5C22544A-7EE6-4342-B048-85BDC9FD1C3A}</a:tableStyleId>
               </a:tblPr>
               <a:tblGrid>
-                <a:gridCol w="3200400"/>
-                <a:gridCol w="6156655"/>
+                <a:gridCol w="3108960"/>
+                <a:gridCol w="6248095"/>
                 <a:gridCol w="1371600"/>
               </a:tblGrid>
-              <a:tr h="528320">
+              <a:tr h="548640">
                 <a:tc>
                   <a:txBody>
                     <a:bodyPr/>
@@ -3339,7 +3358,7 @@
                   </a:tcPr>
                 </a:tc>
               </a:tr>
-              <a:tr h="528320">
+              <a:tr h="548640">
                 <a:tc>
                   <a:txBody>
                     <a:bodyPr/>
@@ -3410,7 +3429,7 @@
                   </a:tcPr>
                 </a:tc>
               </a:tr>
-              <a:tr h="528320">
+              <a:tr h="548640">
                 <a:tc>
                   <a:txBody>
                     <a:bodyPr/>
@@ -3481,7 +3500,7 @@
                   </a:tcPr>
                 </a:tc>
               </a:tr>
-              <a:tr h="528320">
+              <a:tr h="548640">
                 <a:tc>
                   <a:txBody>
                     <a:bodyPr/>
@@ -3552,7 +3571,7 @@
                   </a:tcPr>
                 </a:tc>
               </a:tr>
-              <a:tr h="528320">
+              <a:tr h="548640">
                 <a:tc>
                   <a:txBody>
                     <a:bodyPr/>
@@ -3623,7 +3642,7 @@
                   </a:tcPr>
                 </a:tc>
               </a:tr>
-              <a:tr h="528320">
+              <a:tr h="548640">
                 <a:tc>
                   <a:txBody>
                     <a:bodyPr/>
@@ -3694,7 +3713,7 @@
                   </a:tcPr>
                 </a:tc>
               </a:tr>
-              <a:tr h="528320">
+              <a:tr h="548640">
                 <a:tc>
                   <a:txBody>
                     <a:bodyPr/>
@@ -3708,7 +3727,7 @@
                         </a:defRPr>
                       </a:pPr>
                       <a:r>
-                        <a:t>6. Cloud Run Hosting</a:t>
+                        <a:t>6. Production Cloud Run Hosting</a:t>
                       </a:r>
                     </a:p>
                   </a:txBody>
@@ -3765,7 +3784,7 @@
                   </a:tcPr>
                 </a:tc>
               </a:tr>
-              <a:tr h="528320">
+              <a:tr h="548640">
                 <a:tc>
                   <a:txBody>
                     <a:bodyPr/>
@@ -3836,7 +3855,7 @@
                   </a:tcPr>
                 </a:tc>
               </a:tr>
-              <a:tr h="528320">
+              <a:tr h="548640">
                 <a:tc>
                   <a:txBody>
                     <a:bodyPr/>
@@ -3945,8 +3964,8 @@
         </p:nvSpPr>
         <p:spPr>
           <a:xfrm>
-            <a:off x="731520" y="457200"/>
-            <a:ext cx="10698480" cy="914400"/>
+            <a:off x="731520" y="365760"/>
+            <a:ext cx="10698480" cy="822960"/>
           </a:xfrm>
           <a:prstGeom prst="rect">
             <a:avLst/>
@@ -3954,34 +3973,70 @@
           <a:noFill/>
         </p:spPr>
         <p:txBody>
-          <a:bodyPr wrap="none">
+          <a:bodyPr wrap="square">
             <a:spAutoFit/>
           </a:bodyPr>
           <a:lstStyle/>
           <a:p>
             <a:pPr>
-              <a:defRPr sz="2400" b="1">
+              <a:defRPr sz="1100" b="1">
+                <a:solidFill>
+                  <a:srgbClr val="2563EB"/>
+                </a:solidFill>
+              </a:defRPr>
+            </a:pPr>
+            <a:r>
+              <a:t>HARMONY — PERSONAL JOURNAL AUDITING WEB APP</a:t>
+            </a:r>
+          </a:p>
+          <a:p>
+            <a:pPr>
+              <a:defRPr sz="2200" b="1">
                 <a:solidFill>
                   <a:srgbClr val="0F172A"/>
                 </a:solidFill>
               </a:defRPr>
             </a:pPr>
             <a:r>
-              <a:t>🏗️ Architecture &amp; Security Model</a:t>
-            </a:r>
-          </a:p>
-        </p:txBody>
-      </p:sp>
-      <p:sp>
-        <p:nvSpPr>
-          <p:cNvPr id="3" name="TextBox 2"/>
+              <a:t>🏗️ Architecture Topology &amp; Security Model</a:t>
+            </a:r>
+          </a:p>
+        </p:txBody>
+      </p:sp>
+      <p:pic>
+        <p:nvPicPr>
+          <p:cNvPr id="3" name="Picture 2" descr="harmony_architecture_diagram.jpg"/>
+          <p:cNvPicPr>
+            <a:picLocks noChangeAspect="1"/>
+          </p:cNvPicPr>
+          <p:nvPr/>
+        </p:nvPicPr>
+        <p:blipFill>
+          <a:blip r:embed="rId2"/>
+          <a:stretch>
+            <a:fillRect/>
+          </a:stretch>
+        </p:blipFill>
+        <p:spPr>
+          <a:xfrm>
+            <a:off x="731520" y="1280160"/>
+            <a:ext cx="6583680" cy="5029200"/>
+          </a:xfrm>
+          <a:prstGeom prst="rect">
+            <a:avLst/>
+          </a:prstGeom>
+        </p:spPr>
+      </p:pic>
+      <p:sp>
+        <p:nvSpPr>
+          <p:cNvPr id="4" name="TextBox 3"/>
           <p:cNvSpPr txBox="1"/>
           <p:nvPr/>
         </p:nvSpPr>
         <p:spPr>
           <a:xfrm>
-            <a:off x="731520" y="1371600"/>
-            <a:ext cx="10728655" cy="4846320"/>
+            <a:off x="7498079" y="1280160"/>
+            <a:ext cx="3931920" cy="5029200"/>
           </a:xfrm>
           <a:prstGeom prst="rect">
             <a:avLst/>
@@ -3994,121 +4049,153 @@
           </a:bodyPr>
           <a:lstStyle/>
           <a:p>
-            <a:br/>
             <a:pPr>
+              <a:spcAft>
+                <a:spcPts val="200"/>
+              </a:spcAft>
+              <a:defRPr sz="1300" b="1">
+                <a:solidFill>
+                  <a:srgbClr val="2563EB"/>
+                </a:solidFill>
+              </a:defRPr>
+            </a:pPr>
+            <a:r>
+              <a:t>🌐 Client Browser</a:t>
+            </a:r>
+          </a:p>
+          <a:p>
+            <a:pPr>
+              <a:spcAft>
+                <a:spcPts val="1000"/>
+              </a:spcAft>
               <a:defRPr sz="1100">
                 <a:solidFill>
-                  <a:srgbClr val="0F172A"/>
+                  <a:srgbClr val="1E293B"/>
                 </a:solidFill>
-                <a:latin typeface="Courier New"/>
               </a:defRPr>
             </a:pPr>
             <a:r>
-              <a:t>┌─────────────────────────────────────────────────────────────────────────────────────────┐</a:t>
-            </a:r>
-            <a:br/>
-            <a:r>
-              <a:t>│                                     Client Browser                                      │</a:t>
-            </a:r>
-            <a:br/>
-            <a:r>
-              <a:t>│  ┌───────────────────────────────────────────────────────────────────────────────────┐  │</a:t>
-            </a:r>
-            <a:br/>
-            <a:r>
-              <a:t>│  │   Harmony UI (Next.js 16, Tailwind, Framer Motion, Recharts)                      │  │</a:t>
-            </a:r>
-            <a:br/>
-            <a:r>
-              <a:t>│  └─────────────────────────────────────────┬─────────────────────────────────────────┘  │</a:t>
-            </a:r>
-            <a:br/>
-            <a:r>
-              <a:t>└────────────────────────────────────────────┼────────────────────────────────────────────┘</a:t>
-            </a:r>
-            <a:br/>
-            <a:r>
-              <a:t>                                             │ HTTPS</a:t>
-            </a:r>
-            <a:br/>
-            <a:r>
-              <a:t>┌────────────────────────────────────────────▼────────────────────────────────────────────┐</a:t>
-            </a:r>
-            <a:br/>
-            <a:r>
-              <a:t>│                                Google Cloud Run Service                                 │</a:t>
-            </a:r>
-            <a:br/>
-            <a:r>
-              <a:t>│                   (Label: dev-tutorial=cloud-run-ai-challenge)                          │</a:t>
-            </a:r>
-            <a:br/>
-            <a:r>
-              <a:t>│  ┌─────────────────────────────────┐               ┌─────────────────────────────────┐  │</a:t>
-            </a:r>
-            <a:br/>
-            <a:r>
-              <a:t>│  │ Firebase Client/Admin           │               │  Gemini API SDK Integration     │  │</a:t>
-            </a:r>
-            <a:br/>
-            <a:r>
-              <a:t>│  └────────────────┬────────────────┘               └────────────────┬────────────────┘  │</a:t>
-            </a:r>
-            <a:br/>
-            <a:r>
-              <a:t>└───────────────────┼─────────────────────────────────────────────────┼───────────────────┘</a:t>
-            </a:r>
-            <a:br/>
-            <a:r>
-              <a:t>                    │                                                 │</a:t>
-            </a:r>
-            <a:br/>
-            <a:r>
-              <a:t>┌───────────────────▼────────────────┐               ┌────────────────▼──────────────────┐</a:t>
-            </a:r>
-            <a:br/>
-            <a:r>
-              <a:t>│      Firebase Auth Service         │               │     Google AI Studio /            │</a:t>
-            </a:r>
-            <a:br/>
-            <a:r>
-              <a:t>│      (Google &amp; Email Auth)         │               │     Gemini API                    │</a:t>
-            </a:r>
-            <a:br/>
-            <a:r>
-              <a:t>└───────────────────┬────────────────┘               └───────────────────────────────────┘</a:t>
-            </a:r>
-            <a:br/>
-            <a:r>
-              <a:t>                    │ UID Context</a:t>
-            </a:r>
-            <a:br/>
-            <a:r>
-              <a:t>┌───────────────────▼────────────────┐               ┌───────────────────────────────────┐</a:t>
-            </a:r>
-            <a:br/>
-            <a:r>
-              <a:t>│        Cloud Firestore             │               │       Cloud Secret Manager        │</a:t>
-            </a:r>
-            <a:br/>
-            <a:r>
-              <a:t>│  /users/{uid}/journals/{id}        │               │       (GEMINI_API_KEY)            │</a:t>
-            </a:r>
-            <a:br/>
-            <a:r>
-              <a:t>│  Strict Firestore Security Rules   │               │       roles/secretmanager.        │</a:t>
-            </a:r>
-            <a:br/>
-            <a:r>
-              <a:t>│                                    │               │       secretAccessor              │</a:t>
-            </a:r>
-            <a:br/>
-            <a:r>
-              <a:t>└────────────────────────────────────┘               └───────────────────────────────────┘</a:t>
-            </a:r>
-            <a:br/>
-            <a:r>
-              <a:t>    </a:t>
+              <a:t>Next.js 16, React 19, Tailwind CSS, Framer Motion &amp; Recharts data visualization.</a:t>
+            </a:r>
+          </a:p>
+          <a:p>
+            <a:pPr>
+              <a:spcAft>
+                <a:spcPts val="200"/>
+              </a:spcAft>
+              <a:defRPr sz="1300" b="1">
+                <a:solidFill>
+                  <a:srgbClr val="2563EB"/>
+                </a:solidFill>
+              </a:defRPr>
+            </a:pPr>
+            <a:r>
+              <a:t>🚀 Cloud Run Hosting</a:t>
+            </a:r>
+          </a:p>
+          <a:p>
+            <a:pPr>
+              <a:spcAft>
+                <a:spcPts val="1000"/>
+              </a:spcAft>
+              <a:defRPr sz="1100">
+                <a:solidFill>
+                  <a:srgbClr val="1E293B"/>
+                </a:solidFill>
+              </a:defRPr>
+            </a:pPr>
+            <a:r>
+              <a:t>Containerized service running on asia-south1 with service identity personal-gemini-journal-sa.</a:t>
+            </a:r>
+          </a:p>
+          <a:p>
+            <a:pPr>
+              <a:spcAft>
+                <a:spcPts val="200"/>
+              </a:spcAft>
+              <a:defRPr sz="1300" b="1">
+                <a:solidFill>
+                  <a:srgbClr val="2563EB"/>
+                </a:solidFill>
+              </a:defRPr>
+            </a:pPr>
+            <a:r>
+              <a:t>🔐 Firebase Authentication</a:t>
+            </a:r>
+          </a:p>
+          <a:p>
+            <a:pPr>
+              <a:spcAft>
+                <a:spcPts val="1000"/>
+              </a:spcAft>
+              <a:defRPr sz="1100">
+                <a:solidFill>
+                  <a:srgbClr val="1E293B"/>
+                </a:solidFill>
+              </a:defRPr>
+            </a:pPr>
+            <a:r>
+              <a:t>Federated Google Sign-In &amp; Email/Password session management binding user state to Firebase UID.</a:t>
+            </a:r>
+          </a:p>
+          <a:p>
+            <a:pPr>
+              <a:spcAft>
+                <a:spcPts val="200"/>
+              </a:spcAft>
+              <a:defRPr sz="1300" b="1">
+                <a:solidFill>
+                  <a:srgbClr val="2563EB"/>
+                </a:solidFill>
+              </a:defRPr>
+            </a:pPr>
+            <a:r>
+              <a:t>🛡️ Isolated Cloud Firestore</a:t>
+            </a:r>
+          </a:p>
+          <a:p>
+            <a:pPr>
+              <a:spcAft>
+                <a:spcPts val="1000"/>
+              </a:spcAft>
+              <a:defRPr sz="1100">
+                <a:solidFill>
+                  <a:srgbClr val="1E293B"/>
+                </a:solidFill>
+              </a:defRPr>
+            </a:pPr>
+            <a:r>
+              <a:t>Strict database security rules enforcing request.auth.uid == userId to eliminate cross-tenant leakage.</a:t>
+            </a:r>
+          </a:p>
+          <a:p>
+            <a:pPr>
+              <a:spcAft>
+                <a:spcPts val="200"/>
+              </a:spcAft>
+              <a:defRPr sz="1300" b="1">
+                <a:solidFill>
+                  <a:srgbClr val="2563EB"/>
+                </a:solidFill>
+              </a:defRPr>
+            </a:pPr>
+            <a:r>
+              <a:t>🔑 Secret Manager API</a:t>
+            </a:r>
+          </a:p>
+          <a:p>
+            <a:pPr>
+              <a:spcAft>
+                <a:spcPts val="1000"/>
+              </a:spcAft>
+              <a:defRPr sz="1100">
+                <a:solidFill>
+                  <a:srgbClr val="1E293B"/>
+                </a:solidFill>
+              </a:defRPr>
+            </a:pPr>
+            <a:r>
+              <a:t>GEMINI_API_KEY fetched at runtime via SecretAccessor IAM role with zero hardcoded keys.</a:t>
             </a:r>
           </a:p>
         </p:txBody>
@@ -4147,8 +4234,8 @@
         </p:nvSpPr>
         <p:spPr>
           <a:xfrm>
-            <a:off x="731520" y="457200"/>
-            <a:ext cx="10698480" cy="914400"/>
+            <a:off x="731520" y="365760"/>
+            <a:ext cx="10698480" cy="822960"/>
           </a:xfrm>
           <a:prstGeom prst="rect">
             <a:avLst/>
@@ -4156,20 +4243,32 @@
           <a:noFill/>
         </p:spPr>
         <p:txBody>
-          <a:bodyPr wrap="none">
+          <a:bodyPr wrap="square">
             <a:spAutoFit/>
           </a:bodyPr>
           <a:lstStyle/>
           <a:p>
             <a:pPr>
-              <a:defRPr sz="2400" b="1">
+              <a:defRPr sz="1100" b="1">
+                <a:solidFill>
+                  <a:srgbClr val="2563EB"/>
+                </a:solidFill>
+              </a:defRPr>
+            </a:pPr>
+            <a:r>
+              <a:t>HARMONY — PERSONAL JOURNAL AUDITING WEB APP</a:t>
+            </a:r>
+          </a:p>
+          <a:p>
+            <a:pPr>
+              <a:defRPr sz="2200" b="1">
                 <a:solidFill>
                   <a:srgbClr val="0F172A"/>
                 </a:solidFill>
               </a:defRPr>
             </a:pPr>
             <a:r>
-              <a:t>🔒 Security Verification Matrix</a:t>
+              <a:t>🔒 Security Verification Matrix &amp; Zero-Trust Bounds</a:t>
             </a:r>
           </a:p>
         </p:txBody>
@@ -4183,8 +4282,8 @@
           <p:nvPr/>
         </p:nvGraphicFramePr>
         <p:xfrm>
-          <a:off x="731520" y="1463040"/>
-          <a:ext cx="10728655" cy="4389120"/>
+          <a:off x="731520" y="1371600"/>
+          <a:ext cx="10728655" cy="4754880"/>
         </p:xfrm>
         <a:graphic>
           <a:graphicData uri="http://schemas.openxmlformats.org/drawingml/2006/table">
@@ -4198,14 +4297,14 @@
                 <a:gridCol w="2956255"/>
                 <a:gridCol w="1097280"/>
               </a:tblGrid>
-              <a:tr h="731520">
+              <a:tr h="792480">
                 <a:tc>
                   <a:txBody>
                     <a:bodyPr/>
                     <a:lstStyle/>
                     <a:p>
                       <a:pPr>
-                        <a:defRPr b="1" sz="1300">
+                        <a:defRPr b="1" sz="1200">
                           <a:solidFill>
                             <a:srgbClr val="FFFFFF"/>
                           </a:solidFill>
@@ -4228,7 +4327,7 @@
                     <a:lstStyle/>
                     <a:p>
                       <a:pPr>
-                        <a:defRPr b="1" sz="1300">
+                        <a:defRPr b="1" sz="1200">
                           <a:solidFill>
                             <a:srgbClr val="FFFFFF"/>
                           </a:solidFill>
@@ -4251,7 +4350,7 @@
                     <a:lstStyle/>
                     <a:p>
                       <a:pPr>
-                        <a:defRPr b="1" sz="1300">
+                        <a:defRPr b="1" sz="1200">
                           <a:solidFill>
                             <a:srgbClr val="FFFFFF"/>
                           </a:solidFill>
@@ -4274,7 +4373,7 @@
                     <a:lstStyle/>
                     <a:p>
                       <a:pPr>
-                        <a:defRPr b="1" sz="1300">
+                        <a:defRPr b="1" sz="1200">
                           <a:solidFill>
                             <a:srgbClr val="FFFFFF"/>
                           </a:solidFill>
@@ -4292,14 +4391,14 @@
                   </a:tcPr>
                 </a:tc>
               </a:tr>
-              <a:tr h="731520">
+              <a:tr h="792480">
                 <a:tc>
                   <a:txBody>
                     <a:bodyPr/>
                     <a:lstStyle/>
                     <a:p>
                       <a:pPr>
-                        <a:defRPr sz="1200">
+                        <a:defRPr sz="1100">
                           <a:solidFill>
                             <a:srgbClr val="1E293B"/>
                           </a:solidFill>
@@ -4322,7 +4421,7 @@
                     <a:lstStyle/>
                     <a:p>
                       <a:pPr>
-                        <a:defRPr sz="1200">
+                        <a:defRPr sz="1100">
                           <a:solidFill>
                             <a:srgbClr val="1E293B"/>
                           </a:solidFill>
@@ -4345,7 +4444,7 @@
                     <a:lstStyle/>
                     <a:p>
                       <a:pPr>
-                        <a:defRPr sz="1200">
+                        <a:defRPr sz="1100">
                           <a:solidFill>
                             <a:srgbClr val="1E293B"/>
                           </a:solidFill>
@@ -4368,7 +4467,7 @@
                     <a:lstStyle/>
                     <a:p>
                       <a:pPr>
-                        <a:defRPr sz="1200" b="1">
+                        <a:defRPr sz="1100" b="1">
                           <a:solidFill>
                             <a:srgbClr val="16A34A"/>
                           </a:solidFill>
@@ -4386,14 +4485,14 @@
                   </a:tcPr>
                 </a:tc>
               </a:tr>
-              <a:tr h="731520">
+              <a:tr h="792480">
                 <a:tc>
                   <a:txBody>
                     <a:bodyPr/>
                     <a:lstStyle/>
                     <a:p>
                       <a:pPr>
-                        <a:defRPr sz="1200">
+                        <a:defRPr sz="1100">
                           <a:solidFill>
                             <a:srgbClr val="1E293B"/>
                           </a:solidFill>
@@ -4416,7 +4515,7 @@
                     <a:lstStyle/>
                     <a:p>
                       <a:pPr>
-                        <a:defRPr sz="1200">
+                        <a:defRPr sz="1100">
                           <a:solidFill>
                             <a:srgbClr val="1E293B"/>
                           </a:solidFill>
@@ -4439,7 +4538,7 @@
                     <a:lstStyle/>
                     <a:p>
                       <a:pPr>
-                        <a:defRPr sz="1200">
+                        <a:defRPr sz="1100">
                           <a:solidFill>
                             <a:srgbClr val="1E293B"/>
                           </a:solidFill>
@@ -4462,7 +4561,7 @@
                     <a:lstStyle/>
                     <a:p>
                       <a:pPr>
-                        <a:defRPr sz="1200" b="1">
+                        <a:defRPr sz="1100" b="1">
                           <a:solidFill>
                             <a:srgbClr val="16A34A"/>
                           </a:solidFill>
@@ -4480,14 +4579,14 @@
                   </a:tcPr>
                 </a:tc>
               </a:tr>
-              <a:tr h="731520">
+              <a:tr h="792480">
                 <a:tc>
                   <a:txBody>
                     <a:bodyPr/>
                     <a:lstStyle/>
                     <a:p>
                       <a:pPr>
-                        <a:defRPr sz="1200">
+                        <a:defRPr sz="1100">
                           <a:solidFill>
                             <a:srgbClr val="1E293B"/>
                           </a:solidFill>
@@ -4510,7 +4609,7 @@
                     <a:lstStyle/>
                     <a:p>
                       <a:pPr>
-                        <a:defRPr sz="1200">
+                        <a:defRPr sz="1100">
                           <a:solidFill>
                             <a:srgbClr val="1E293B"/>
                           </a:solidFill>
@@ -4533,7 +4632,7 @@
                     <a:lstStyle/>
                     <a:p>
                       <a:pPr>
-                        <a:defRPr sz="1200">
+                        <a:defRPr sz="1100">
                           <a:solidFill>
                             <a:srgbClr val="1E293B"/>
                           </a:solidFill>
@@ -4556,7 +4655,7 @@
                     <a:lstStyle/>
                     <a:p>
                       <a:pPr>
-                        <a:defRPr sz="1200" b="1">
+                        <a:defRPr sz="1100" b="1">
                           <a:solidFill>
                             <a:srgbClr val="16A34A"/>
                           </a:solidFill>
@@ -4574,14 +4673,14 @@
                   </a:tcPr>
                 </a:tc>
               </a:tr>
-              <a:tr h="731520">
+              <a:tr h="792480">
                 <a:tc>
                   <a:txBody>
                     <a:bodyPr/>
                     <a:lstStyle/>
                     <a:p>
                       <a:pPr>
-                        <a:defRPr sz="1200">
+                        <a:defRPr sz="1100">
                           <a:solidFill>
                             <a:srgbClr val="1E293B"/>
                           </a:solidFill>
@@ -4604,7 +4703,7 @@
                     <a:lstStyle/>
                     <a:p>
                       <a:pPr>
-                        <a:defRPr sz="1200">
+                        <a:defRPr sz="1100">
                           <a:solidFill>
                             <a:srgbClr val="1E293B"/>
                           </a:solidFill>
@@ -4627,7 +4726,7 @@
                     <a:lstStyle/>
                     <a:p>
                       <a:pPr>
-                        <a:defRPr sz="1200">
+                        <a:defRPr sz="1100">
                           <a:solidFill>
                             <a:srgbClr val="1E293B"/>
                           </a:solidFill>
@@ -4650,7 +4749,7 @@
                     <a:lstStyle/>
                     <a:p>
                       <a:pPr>
-                        <a:defRPr sz="1200" b="1">
+                        <a:defRPr sz="1100" b="1">
                           <a:solidFill>
                             <a:srgbClr val="16A34A"/>
                           </a:solidFill>
@@ -4668,14 +4767,14 @@
                   </a:tcPr>
                 </a:tc>
               </a:tr>
-              <a:tr h="731520">
+              <a:tr h="792480">
                 <a:tc>
                   <a:txBody>
                     <a:bodyPr/>
                     <a:lstStyle/>
                     <a:p>
                       <a:pPr>
-                        <a:defRPr sz="1200">
+                        <a:defRPr sz="1100">
                           <a:solidFill>
                             <a:srgbClr val="1E293B"/>
                           </a:solidFill>
@@ -4698,7 +4797,7 @@
                     <a:lstStyle/>
                     <a:p>
                       <a:pPr>
-                        <a:defRPr sz="1200">
+                        <a:defRPr sz="1100">
                           <a:solidFill>
                             <a:srgbClr val="1E293B"/>
                           </a:solidFill>
@@ -4721,7 +4820,7 @@
                     <a:lstStyle/>
                     <a:p>
                       <a:pPr>
-                        <a:defRPr sz="1200">
+                        <a:defRPr sz="1100">
                           <a:solidFill>
                             <a:srgbClr val="1E293B"/>
                           </a:solidFill>
@@ -4744,7 +4843,7 @@
                     <a:lstStyle/>
                     <a:p>
                       <a:pPr>
-                        <a:defRPr sz="1200" b="1">
+                        <a:defRPr sz="1100" b="1">
                           <a:solidFill>
                             <a:srgbClr val="16A34A"/>
                           </a:solidFill>
@@ -4800,8 +4899,8 @@
         </p:nvSpPr>
         <p:spPr>
           <a:xfrm>
-            <a:off x="731520" y="457200"/>
-            <a:ext cx="10698480" cy="914400"/>
+            <a:off x="731520" y="365760"/>
+            <a:ext cx="10698480" cy="822960"/>
           </a:xfrm>
           <a:prstGeom prst="rect">
             <a:avLst/>
@@ -4809,34 +4908,94 @@
           <a:noFill/>
         </p:spPr>
         <p:txBody>
-          <a:bodyPr wrap="none">
+          <a:bodyPr wrap="square">
             <a:spAutoFit/>
           </a:bodyPr>
           <a:lstStyle/>
           <a:p>
             <a:pPr>
-              <a:defRPr sz="2400" b="1">
+              <a:defRPr sz="1100" b="1">
+                <a:solidFill>
+                  <a:srgbClr val="2563EB"/>
+                </a:solidFill>
+              </a:defRPr>
+            </a:pPr>
+            <a:r>
+              <a:t>HARMONY — PERSONAL JOURNAL AUDITING WEB APP</a:t>
+            </a:r>
+          </a:p>
+          <a:p>
+            <a:pPr>
+              <a:defRPr sz="2200" b="1">
                 <a:solidFill>
                   <a:srgbClr val="0F172A"/>
                 </a:solidFill>
               </a:defRPr>
             </a:pPr>
             <a:r>
-              <a:t>🌟 Core Features &amp; Digital Auditing Workspace</a:t>
-            </a:r>
-          </a:p>
-        </p:txBody>
-      </p:sp>
-      <p:sp>
-        <p:nvSpPr>
-          <p:cNvPr id="3" name="TextBox 2"/>
+              <a:t>💬 Intelligent Journal Auditing &amp; Reflection Engine</a:t>
+            </a:r>
+          </a:p>
+        </p:txBody>
+      </p:sp>
+      <p:pic>
+        <p:nvPicPr>
+          <p:cNvPr id="3" name="Picture 2" descr="Screenshot 2026-08-30 155434.png"/>
+          <p:cNvPicPr>
+            <a:picLocks noChangeAspect="1"/>
+          </p:cNvPicPr>
+          <p:nvPr/>
+        </p:nvPicPr>
+        <p:blipFill>
+          <a:blip r:embed="rId2"/>
+          <a:stretch>
+            <a:fillRect/>
+          </a:stretch>
+        </p:blipFill>
+        <p:spPr>
+          <a:xfrm>
+            <a:off x="731520" y="1280160"/>
+            <a:ext cx="5212080" cy="3291840"/>
+          </a:xfrm>
+          <a:prstGeom prst="rect">
+            <a:avLst/>
+          </a:prstGeom>
+        </p:spPr>
+      </p:pic>
+      <p:pic>
+        <p:nvPicPr>
+          <p:cNvPr id="4" name="Picture 3" descr="Screenshot 2026-08-30 155448.png"/>
+          <p:cNvPicPr>
+            <a:picLocks noChangeAspect="1"/>
+          </p:cNvPicPr>
+          <p:nvPr/>
+        </p:nvPicPr>
+        <p:blipFill>
+          <a:blip r:embed="rId3"/>
+          <a:stretch>
+            <a:fillRect/>
+          </a:stretch>
+        </p:blipFill>
+        <p:spPr>
+          <a:xfrm>
+            <a:off x="6217920" y="1280160"/>
+            <a:ext cx="5212080" cy="3291840"/>
+          </a:xfrm>
+          <a:prstGeom prst="rect">
+            <a:avLst/>
+          </a:prstGeom>
+        </p:spPr>
+      </p:pic>
+      <p:sp>
+        <p:nvSpPr>
+          <p:cNvPr id="5" name="TextBox 4"/>
           <p:cNvSpPr txBox="1"/>
           <p:nvPr/>
         </p:nvSpPr>
         <p:spPr>
           <a:xfrm>
-            <a:off x="731520" y="1463040"/>
-            <a:ext cx="5120640" cy="1463040"/>
+            <a:off x="731520" y="4754880"/>
+            <a:ext cx="10728655" cy="1645920"/>
           </a:xfrm>
           <a:prstGeom prst="rect">
             <a:avLst/>
@@ -4850,43 +5009,74 @@
           <a:lstStyle/>
           <a:p>
             <a:pPr>
-              <a:spcAft>
-                <a:spcPts val="400"/>
-              </a:spcAft>
-              <a:defRPr sz="1500" b="1">
+              <a:defRPr sz="1300" b="1">
                 <a:solidFill>
                   <a:srgbClr val="2563EB"/>
                 </a:solidFill>
               </a:defRPr>
             </a:pPr>
             <a:r>
-              <a:t>🤖 Smart Journal Auditing</a:t>
+              <a:t>Key Capabilities:</a:t>
             </a:r>
           </a:p>
           <a:p>
             <a:pPr>
-              <a:defRPr sz="1200">
+              <a:defRPr sz="1100">
                 <a:solidFill>
                   <a:srgbClr val="1E293B"/>
                 </a:solidFill>
               </a:defRPr>
             </a:pPr>
             <a:r>
-              <a:t>Context-aware reflection analysis with auto-extracted daily highlights, checkable tasks, and key milestones.</a:t>
-            </a:r>
-          </a:p>
-        </p:txBody>
-      </p:sp>
-      <p:sp>
-        <p:nvSpPr>
-          <p:cNvPr id="4" name="TextBox 3"/>
+              <a:t>• Multi-Turn Reflection Conversations: Powered by Google Gemini API with system-prompt security constitution.</a:t>
+            </a:r>
+            <a:br/>
+            <a:r>
+              <a:t>• Smart Highlights &amp; Memory: Automatically extracts daily reflection logs, birthdays, and key checkable events into Firestore.</a:t>
+            </a:r>
+            <a:br/>
+            <a:r>
+              <a:t>• Context-Aware Auditing: Past journal history is audited and referenced seamlessly during multi-turn conversations.</a:t>
+            </a:r>
+          </a:p>
+        </p:txBody>
+      </p:sp>
+    </p:spTree>
+  </p:cSld>
+  <p:clrMapOvr>
+    <a:masterClrMapping/>
+  </p:clrMapOvr>
+</p:sld>
+</file>
+
+<file path=ppt/slides/slide6.xml><?xml version="1.0" encoding="utf-8"?>
+<p:sld xmlns:a="http://schemas.openxmlformats.org/drawingml/2006/main" xmlns:p="http://schemas.openxmlformats.org/presentationml/2006/main" xmlns:r="http://schemas.openxmlformats.org/officeDocument/2006/relationships">
+  <p:cSld>
+    <p:bg>
+      <p:bgPr>
+        <a:solidFill>
+          <a:srgbClr val="F8FAFC"/>
+        </a:solidFill>
+        <a:effectLst/>
+      </p:bgPr>
+    </p:bg>
+    <p:spTree>
+      <p:nvGrpSpPr>
+        <p:cNvPr id="1" name=""/>
+        <p:cNvGrpSpPr/>
+        <p:nvPr/>
+      </p:nvGrpSpPr>
+      <p:grpSpPr/>
+      <p:sp>
+        <p:nvSpPr>
+          <p:cNvPr id="2" name="TextBox 1"/>
           <p:cNvSpPr txBox="1"/>
           <p:nvPr/>
         </p:nvSpPr>
         <p:spPr>
           <a:xfrm>
-            <a:off x="6172200" y="1463040"/>
-            <a:ext cx="5120640" cy="1463040"/>
+            <a:off x="731520" y="365760"/>
+            <a:ext cx="10698480" cy="822960"/>
           </a:xfrm>
           <a:prstGeom prst="rect">
             <a:avLst/>
@@ -4900,33 +5090,78 @@
           <a:lstStyle/>
           <a:p>
             <a:pPr>
-              <a:spcAft>
-                <a:spcPts val="400"/>
-              </a:spcAft>
-              <a:defRPr sz="1500" b="1">
+              <a:defRPr sz="1100" b="1">
                 <a:solidFill>
                   <a:srgbClr val="2563EB"/>
                 </a:solidFill>
               </a:defRPr>
             </a:pPr>
             <a:r>
-              <a:t>📈 Interactive Chart Audits</a:t>
+              <a:t>HARMONY — PERSONAL JOURNAL AUDITING WEB APP</a:t>
             </a:r>
           </a:p>
           <a:p>
             <a:pPr>
-              <a:defRPr sz="1200">
+              <a:defRPr sz="2200" b="1">
                 <a:solidFill>
-                  <a:srgbClr val="1E293B"/>
+                  <a:srgbClr val="0F172A"/>
                 </a:solidFill>
               </a:defRPr>
             </a:pPr>
             <a:r>
-              <a:t>Gemini creates visual progress line charts, score trends, and data metrics on demand via Recharts.</a:t>
-            </a:r>
-          </a:p>
-        </p:txBody>
-      </p:sp>
+              <a:t>📈 Visual Progress Analytics &amp; Mood Chart Audits</a:t>
+            </a:r>
+          </a:p>
+        </p:txBody>
+      </p:sp>
+      <p:pic>
+        <p:nvPicPr>
+          <p:cNvPr id="3" name="Picture 2" descr="Screenshot 2026-08-30 155502.png"/>
+          <p:cNvPicPr>
+            <a:picLocks noChangeAspect="1"/>
+          </p:cNvPicPr>
+          <p:nvPr/>
+        </p:nvPicPr>
+        <p:blipFill>
+          <a:blip r:embed="rId2"/>
+          <a:stretch>
+            <a:fillRect/>
+          </a:stretch>
+        </p:blipFill>
+        <p:spPr>
+          <a:xfrm>
+            <a:off x="731520" y="1280160"/>
+            <a:ext cx="5212080" cy="3291840"/>
+          </a:xfrm>
+          <a:prstGeom prst="rect">
+            <a:avLst/>
+          </a:prstGeom>
+        </p:spPr>
+      </p:pic>
+      <p:pic>
+        <p:nvPicPr>
+          <p:cNvPr id="4" name="Picture 3" descr="Screenshot 2026-08-30 155512.png"/>
+          <p:cNvPicPr>
+            <a:picLocks noChangeAspect="1"/>
+          </p:cNvPicPr>
+          <p:nvPr/>
+        </p:nvPicPr>
+        <p:blipFill>
+          <a:blip r:embed="rId3"/>
+          <a:stretch>
+            <a:fillRect/>
+          </a:stretch>
+        </p:blipFill>
+        <p:spPr>
+          <a:xfrm>
+            <a:off x="6217920" y="1280160"/>
+            <a:ext cx="5212080" cy="3291840"/>
+          </a:xfrm>
+          <a:prstGeom prst="rect">
+            <a:avLst/>
+          </a:prstGeom>
+        </p:spPr>
+      </p:pic>
       <p:sp>
         <p:nvSpPr>
           <p:cNvPr id="5" name="TextBox 4"/>
@@ -4935,8 +5170,8 @@
         </p:nvSpPr>
         <p:spPr>
           <a:xfrm>
-            <a:off x="731520" y="3108960"/>
-            <a:ext cx="5120640" cy="1463040"/>
+            <a:off x="731520" y="4754880"/>
+            <a:ext cx="10728655" cy="1645920"/>
           </a:xfrm>
           <a:prstGeom prst="rect">
             <a:avLst/>
@@ -4950,43 +5185,74 @@
           <a:lstStyle/>
           <a:p>
             <a:pPr>
-              <a:spcAft>
-                <a:spcPts val="400"/>
-              </a:spcAft>
-              <a:defRPr sz="1500" b="1">
+              <a:defRPr sz="1300" b="1">
                 <a:solidFill>
                   <a:srgbClr val="2563EB"/>
                 </a:solidFill>
               </a:defRPr>
             </a:pPr>
             <a:r>
-              <a:t>🔒 100% Owner Data Isolation</a:t>
+              <a:t>Key Analytics Capabilities:</a:t>
             </a:r>
           </a:p>
           <a:p>
             <a:pPr>
-              <a:defRPr sz="1200">
+              <a:defRPr sz="1100">
                 <a:solidFill>
                   <a:srgbClr val="1E293B"/>
                 </a:solidFill>
               </a:defRPr>
             </a:pPr>
             <a:r>
-              <a:t>Owner-isolated Firestore document storage (/users/{userId}/*) with strict security rules.</a:t>
-            </a:r>
-          </a:p>
-        </p:txBody>
-      </p:sp>
-      <p:sp>
-        <p:nvSpPr>
-          <p:cNvPr id="6" name="TextBox 5"/>
+              <a:t>• Interactive Progress Charts: Dynamic Recharts line, bar, pie, and scatter analytics rendering mood trends &amp; test score trackers.</a:t>
+            </a:r>
+            <a:br/>
+            <a:r>
+              <a:t>• Time-Decayed Sentiment Scoring: Gemini computes emotional sentiment index over decaying time horizons.</a:t>
+            </a:r>
+            <a:br/>
+            <a:r>
+              <a:t>• Topic Frequency Breakdown: Categorizes daily thoughts into recurring themes (Career, Productivity, Health, Growth).</a:t>
+            </a:r>
+          </a:p>
+        </p:txBody>
+      </p:sp>
+    </p:spTree>
+  </p:cSld>
+  <p:clrMapOvr>
+    <a:masterClrMapping/>
+  </p:clrMapOvr>
+</p:sld>
+</file>
+
+<file path=ppt/slides/slide7.xml><?xml version="1.0" encoding="utf-8"?>
+<p:sld xmlns:a="http://schemas.openxmlformats.org/drawingml/2006/main" xmlns:p="http://schemas.openxmlformats.org/presentationml/2006/main" xmlns:r="http://schemas.openxmlformats.org/officeDocument/2006/relationships">
+  <p:cSld>
+    <p:bg>
+      <p:bgPr>
+        <a:solidFill>
+          <a:srgbClr val="F8FAFC"/>
+        </a:solidFill>
+        <a:effectLst/>
+      </p:bgPr>
+    </p:bg>
+    <p:spTree>
+      <p:nvGrpSpPr>
+        <p:cNvPr id="1" name=""/>
+        <p:cNvGrpSpPr/>
+        <p:nvPr/>
+      </p:nvGrpSpPr>
+      <p:grpSpPr/>
+      <p:sp>
+        <p:nvSpPr>
+          <p:cNvPr id="2" name="TextBox 1"/>
           <p:cNvSpPr txBox="1"/>
           <p:nvPr/>
         </p:nvSpPr>
         <p:spPr>
           <a:xfrm>
-            <a:off x="6172200" y="3108960"/>
-            <a:ext cx="5120640" cy="1463040"/>
+            <a:off x="731520" y="365760"/>
+            <a:ext cx="10698480" cy="822960"/>
           </a:xfrm>
           <a:prstGeom prst="rect">
             <a:avLst/>
@@ -5000,43 +5266,112 @@
           <a:lstStyle/>
           <a:p>
             <a:pPr>
-              <a:spcAft>
-                <a:spcPts val="400"/>
-              </a:spcAft>
-              <a:defRPr sz="1500" b="1">
+              <a:defRPr sz="1100" b="1">
                 <a:solidFill>
                   <a:srgbClr val="2563EB"/>
                 </a:solidFill>
               </a:defRPr>
             </a:pPr>
             <a:r>
-              <a:t>⚡ Firestore Journal Sync</a:t>
+              <a:t>HARMONY — PERSONAL JOURNAL AUDITING WEB APP</a:t>
             </a:r>
           </a:p>
           <a:p>
             <a:pPr>
-              <a:defRPr sz="1200">
+              <a:defRPr sz="2200" b="1">
                 <a:solidFill>
-                  <a:srgbClr val="1E293B"/>
+                  <a:srgbClr val="0F172A"/>
                 </a:solidFill>
               </a:defRPr>
             </a:pPr>
             <a:r>
-              <a:t>Real-time sync across user chat sessions, reflection data logs, and upcoming calendar events.</a:t>
-            </a:r>
-          </a:p>
-        </p:txBody>
-      </p:sp>
-      <p:sp>
-        <p:nvSpPr>
-          <p:cNvPr id="7" name="TextBox 6"/>
+              <a:t>✅ Automated Action Items &amp; Unified Workspace Sync</a:t>
+            </a:r>
+          </a:p>
+        </p:txBody>
+      </p:sp>
+      <p:pic>
+        <p:nvPicPr>
+          <p:cNvPr id="3" name="Picture 2" descr="Screenshot 2026-08-30 155527.png"/>
+          <p:cNvPicPr>
+            <a:picLocks noChangeAspect="1"/>
+          </p:cNvPicPr>
+          <p:nvPr/>
+        </p:nvPicPr>
+        <p:blipFill>
+          <a:blip r:embed="rId2"/>
+          <a:stretch>
+            <a:fillRect/>
+          </a:stretch>
+        </p:blipFill>
+        <p:spPr>
+          <a:xfrm>
+            <a:off x="731520" y="1280160"/>
+            <a:ext cx="3383280" cy="3200400"/>
+          </a:xfrm>
+          <a:prstGeom prst="rect">
+            <a:avLst/>
+          </a:prstGeom>
+        </p:spPr>
+      </p:pic>
+      <p:pic>
+        <p:nvPicPr>
+          <p:cNvPr id="4" name="Picture 3" descr="Screenshot 2026-08-30 155545.png"/>
+          <p:cNvPicPr>
+            <a:picLocks noChangeAspect="1"/>
+          </p:cNvPicPr>
+          <p:nvPr/>
+        </p:nvPicPr>
+        <p:blipFill>
+          <a:blip r:embed="rId3"/>
+          <a:stretch>
+            <a:fillRect/>
+          </a:stretch>
+        </p:blipFill>
+        <p:spPr>
+          <a:xfrm>
+            <a:off x="4389120" y="1280160"/>
+            <a:ext cx="3383280" cy="3200400"/>
+          </a:xfrm>
+          <a:prstGeom prst="rect">
+            <a:avLst/>
+          </a:prstGeom>
+        </p:spPr>
+      </p:pic>
+      <p:pic>
+        <p:nvPicPr>
+          <p:cNvPr id="5" name="Picture 4" descr="Screenshot 2026-08-30 155603.png"/>
+          <p:cNvPicPr>
+            <a:picLocks noChangeAspect="1"/>
+          </p:cNvPicPr>
+          <p:nvPr/>
+        </p:nvPicPr>
+        <p:blipFill>
+          <a:blip r:embed="rId4"/>
+          <a:stretch>
+            <a:fillRect/>
+          </a:stretch>
+        </p:blipFill>
+        <p:spPr>
+          <a:xfrm>
+            <a:off x="8046720" y="1280160"/>
+            <a:ext cx="3383280" cy="3200400"/>
+          </a:xfrm>
+          <a:prstGeom prst="rect">
+            <a:avLst/>
+          </a:prstGeom>
+        </p:spPr>
+      </p:pic>
+      <p:sp>
+        <p:nvSpPr>
+          <p:cNvPr id="6" name="TextBox 5"/>
           <p:cNvSpPr txBox="1"/>
           <p:nvPr/>
         </p:nvSpPr>
         <p:spPr>
           <a:xfrm>
             <a:off x="731520" y="4754880"/>
-            <a:ext cx="5120640" cy="1463040"/>
+            <a:ext cx="10728655" cy="1645920"/>
           </a:xfrm>
           <a:prstGeom prst="rect">
             <a:avLst/>
@@ -5050,43 +5385,74 @@
           <a:lstStyle/>
           <a:p>
             <a:pPr>
-              <a:spcAft>
-                <a:spcPts val="400"/>
-              </a:spcAft>
-              <a:defRPr sz="1500" b="1">
+              <a:defRPr sz="1300" b="1">
                 <a:solidFill>
                   <a:srgbClr val="2563EB"/>
                 </a:solidFill>
               </a:defRPr>
             </a:pPr>
             <a:r>
-              <a:t>🛡️ Firebase Security</a:t>
+              <a:t>Workspace Modules:</a:t>
             </a:r>
           </a:p>
           <a:p>
             <a:pPr>
-              <a:defRPr sz="1200">
+              <a:defRPr sz="1100">
                 <a:solidFill>
                   <a:srgbClr val="1E293B"/>
                 </a:solidFill>
               </a:defRPr>
             </a:pPr>
             <a:r>
-              <a:t>Federated Google Sign-In &amp; Email/Password authentication with zero hardcoded API keys.</a:t>
-            </a:r>
-          </a:p>
-        </p:txBody>
-      </p:sp>
-      <p:sp>
-        <p:nvSpPr>
-          <p:cNvPr id="8" name="TextBox 7"/>
+              <a:t>• Automated Action Items: Gemini extracts implicit/explicit to-dos from conversations directly into checkable checklists.</a:t>
+            </a:r>
+            <a:br/>
+            <a:r>
+              <a:t>• Calendar &amp; Event Sync: Synchronizes daily reflection logs and upcoming milestones with an interactive calendar view.</a:t>
+            </a:r>
+            <a:br/>
+            <a:r>
+              <a:t>• Knowledge Workflows: Search history, compare past entries, export highlights, and copy clean summaries.</a:t>
+            </a:r>
+          </a:p>
+        </p:txBody>
+      </p:sp>
+    </p:spTree>
+  </p:cSld>
+  <p:clrMapOvr>
+    <a:masterClrMapping/>
+  </p:clrMapOvr>
+</p:sld>
+</file>
+
+<file path=ppt/slides/slide8.xml><?xml version="1.0" encoding="utf-8"?>
+<p:sld xmlns:a="http://schemas.openxmlformats.org/drawingml/2006/main" xmlns:p="http://schemas.openxmlformats.org/presentationml/2006/main" xmlns:r="http://schemas.openxmlformats.org/officeDocument/2006/relationships">
+  <p:cSld>
+    <p:bg>
+      <p:bgPr>
+        <a:solidFill>
+          <a:srgbClr val="0F172A"/>
+        </a:solidFill>
+        <a:effectLst/>
+      </p:bgPr>
+    </p:bg>
+    <p:spTree>
+      <p:nvGrpSpPr>
+        <p:cNvPr id="1" name=""/>
+        <p:cNvGrpSpPr/>
+        <p:nvPr/>
+      </p:nvGrpSpPr>
+      <p:grpSpPr/>
+      <p:sp>
+        <p:nvSpPr>
+          <p:cNvPr id="2" name="TextBox 1"/>
           <p:cNvSpPr txBox="1"/>
           <p:nvPr/>
         </p:nvSpPr>
         <p:spPr>
           <a:xfrm>
-            <a:off x="6172200" y="4754880"/>
-            <a:ext cx="5120640" cy="1463040"/>
+            <a:off x="731520" y="548640"/>
+            <a:ext cx="10728655" cy="5760720"/>
           </a:xfrm>
           <a:prstGeom prst="rect">
             <a:avLst/>
@@ -5101,28 +5467,136 @@
           <a:p>
             <a:pPr>
               <a:spcAft>
-                <a:spcPts val="400"/>
+                <a:spcPts val="1600"/>
               </a:spcAft>
-              <a:defRPr sz="1500" b="1">
+              <a:defRPr sz="2200" b="1">
                 <a:solidFill>
-                  <a:srgbClr val="2563EB"/>
+                  <a:srgbClr val="FFFFFF"/>
                 </a:solidFill>
               </a:defRPr>
             </a:pPr>
             <a:r>
-              <a:t>✨ Automated Action Items</a:t>
+              <a:t>🚀 Production Deployment, Impact Metrics &amp; Roadmap</a:t>
+            </a:r>
+          </a:p>
+          <a:p>
+            <a:pPr>
+              <a:spcAft>
+                <a:spcPts val="400"/>
+              </a:spcAft>
+              <a:defRPr sz="1400" b="1">
+                <a:solidFill>
+                  <a:srgbClr val="60A5FA"/>
+                </a:solidFill>
+              </a:defRPr>
+            </a:pPr>
+            <a:r>
+              <a:t>📊 Impact &amp; Scale Metrics:</a:t>
+            </a:r>
+          </a:p>
+          <a:p>
+            <a:pPr>
+              <a:spcAft>
+                <a:spcPts val="1600"/>
+              </a:spcAft>
+              <a:defRPr sz="1200">
+                <a:solidFill>
+                  <a:srgbClr val="CBD5E1"/>
+                </a:solidFill>
+              </a:defRPr>
+            </a:pPr>
+            <a:r>
+              <a:t>• ∞ Personal Memories: Structured daily reflections auto-summarized and safely preserved.</a:t>
+            </a:r>
+            <a:br/>
+            <a:r>
+              <a:t>• 100% UID Privacy: Strict owner-bound Firestore security rules with zero hardcoded keys.</a:t>
+            </a:r>
+            <a:br/>
+            <a:r>
+              <a:t>• 24/7 AI Reflection Companion: Always ready to listen, audit goals, and draw progress charts.</a:t>
+            </a:r>
+          </a:p>
+          <a:p>
+            <a:pPr>
+              <a:spcAft>
+                <a:spcPts val="400"/>
+              </a:spcAft>
+              <a:defRPr sz="1400" b="1">
+                <a:solidFill>
+                  <a:srgbClr val="60A5FA"/>
+                </a:solidFill>
+              </a:defRPr>
+            </a:pPr>
+            <a:r>
+              <a:t>🛠️ Production Cloud Run Deployment Reference:</a:t>
+            </a:r>
+          </a:p>
+          <a:p>
+            <a:pPr>
+              <a:spcAft>
+                <a:spcPts val="1600"/>
+              </a:spcAft>
+              <a:defRPr sz="1000">
+                <a:solidFill>
+                  <a:srgbClr val="94A3B8"/>
+                </a:solidFill>
+                <a:latin typeface="Courier New"/>
+              </a:defRPr>
+            </a:pPr>
+            <a:r>
+              <a:t>gcloud run deploy personal-gemini-journal \</a:t>
+            </a:r>
+            <a:br/>
+            <a:r>
+              <a:t>  --source . --region asia-south1 --platform managed \</a:t>
+            </a:r>
+            <a:br/>
+            <a:r>
+              <a:t>  --service-account personal-gemini-journal-sa@ai-barista-track-1.iam.gserviceaccount.com \</a:t>
+            </a:r>
+            <a:br/>
+            <a:r>
+              <a:t>  --set-secrets GEMINI_API_KEY=GEMINI_API_KEY:latest \</a:t>
+            </a:r>
+            <a:br/>
+            <a:r>
+              <a:t>  --update-labels dev-tutorial=cloud-run-ai-challenge</a:t>
+            </a:r>
+          </a:p>
+          <a:p>
+            <a:pPr>
+              <a:spcAft>
+                <a:spcPts val="400"/>
+              </a:spcAft>
+              <a:defRPr sz="1400" b="1">
+                <a:solidFill>
+                  <a:srgbClr val="60A5FA"/>
+                </a:solidFill>
+              </a:defRPr>
+            </a:pPr>
+            <a:r>
+              <a:t>🔮 Future Engineering Roadmap:</a:t>
             </a:r>
           </a:p>
           <a:p>
             <a:pPr>
               <a:defRPr sz="1200">
                 <a:solidFill>
-                  <a:srgbClr val="1E293B"/>
+                  <a:srgbClr val="CBD5E1"/>
                 </a:solidFill>
               </a:defRPr>
             </a:pPr>
             <a:r>
-              <a:t>Parses conversation turns to identify implicit and explicit to-do items, populating checkable lists.</a:t>
+              <a:t>• Vertex AI Vector Search: Natural language semantic querying across historical entries.</a:t>
+            </a:r>
+            <a:br/>
+            <a:r>
+              <a:t>• Real-Time Voice Reflection Mode: Speech-to-text input for hands-free journaling.</a:t>
+            </a:r>
+            <a:br/>
+            <a:r>
+              <a:t>• Mobile App &amp; Offline Cache Sync: Progressive Web App (PWA) with offline Firestore cache.</a:t>
             </a:r>
           </a:p>
         </p:txBody>

</xml_diff>

<commit_message>
docs: update project deck presentation
</commit_message>
<xml_diff>
--- a/Harmony_Project_Deck_Architecture.pptx
+++ b/Harmony_Project_Deck_Architecture.pptx
@@ -5,16 +5,16 @@
     <p:sldMasterId id="2147483648" r:id="rId1"/>
   </p:sldMasterIdLst>
   <p:sldIdLst>
-    <p:sldId id="256" r:id="rId7"/>
-    <p:sldId id="257" r:id="rId8"/>
-    <p:sldId id="258" r:id="rId9"/>
-    <p:sldId id="259" r:id="rId10"/>
-    <p:sldId id="260" r:id="rId11"/>
-    <p:sldId id="261" r:id="rId12"/>
-    <p:sldId id="262" r:id="rId13"/>
-    <p:sldId id="263" r:id="rId14"/>
+    <p:sldId id="256" r:id="rId2"/>
+    <p:sldId id="257" r:id="rId3"/>
+    <p:sldId id="258" r:id="rId4"/>
+    <p:sldId id="259" r:id="rId5"/>
+    <p:sldId id="260" r:id="rId6"/>
+    <p:sldId id="261" r:id="rId7"/>
+    <p:sldId id="262" r:id="rId8"/>
+    <p:sldId id="263" r:id="rId9"/>
   </p:sldIdLst>
-  <p:sldSz cx="12191695" cy="6858000" type="screen4x3"/>
+  <p:sldSz cx="12192000" cy="6858000"/>
   <p:notesSz cx="6858000" cy="9144000"/>
   <p:defaultTextStyle>
     <a:defPPr>
@@ -111,6 +111,22 @@
       </a:defRPr>
     </a:lvl9pPr>
   </p:defaultTextStyle>
+  <p:extLst>
+    <p:ext uri="{EFAFB233-063F-42B5-8137-9DF3F51BA10A}">
+      <p15:sldGuideLst xmlns:p15="http://schemas.microsoft.com/office/powerpoint/2012/main">
+        <p15:guide id="1" orient="horz" pos="2160">
+          <p15:clr>
+            <a:srgbClr val="A4A3A4"/>
+          </p15:clr>
+        </p15:guide>
+        <p15:guide id="2" pos="2880">
+          <p15:clr>
+            <a:srgbClr val="A4A3A4"/>
+          </p15:clr>
+        </p15:guide>
+      </p15:sldGuideLst>
+    </p:ext>
+  </p:extLst>
 </p:presentation>
 </file>
 
@@ -152,10 +168,9 @@
           <a:lstStyle/>
           <a:p>
             <a:r>
-              <a:rPr lang="en-US" smtClean="0"/>
+              <a:rPr lang="en-US"/>
               <a:t>Click to edit Master title style</a:t>
             </a:r>
-            <a:endParaRPr lang="en-US"/>
           </a:p>
         </p:txBody>
       </p:sp>
@@ -271,10 +286,9 @@
           </a:lstStyle>
           <a:p>
             <a:r>
-              <a:rPr lang="en-US" smtClean="0"/>
+              <a:rPr lang="en-US"/>
               <a:t>Click to edit Master subtitle style</a:t>
             </a:r>
-            <a:endParaRPr lang="en-US"/>
           </a:p>
         </p:txBody>
       </p:sp>
@@ -295,7 +309,7 @@
           <a:p>
             <a:fld id="{5BCAD085-E8A6-8845-BD4E-CB4CCA059FC4}" type="datetimeFigureOut">
               <a:rPr lang="en-US" smtClean="0"/>
-              <a:t>1/27/13</a:t>
+              <a:t>8/30/2026</a:t>
             </a:fld>
             <a:endParaRPr lang="en-US"/>
           </a:p>
@@ -389,10 +403,9 @@
           <a:lstStyle/>
           <a:p>
             <a:r>
-              <a:rPr lang="en-US" smtClean="0"/>
+              <a:rPr lang="en-US"/>
               <a:t>Click to edit Master title style</a:t>
             </a:r>
-            <a:endParaRPr lang="en-US"/>
           </a:p>
         </p:txBody>
       </p:sp>
@@ -413,38 +426,37 @@
           <a:p>
             <a:pPr lvl="0"/>
             <a:r>
-              <a:rPr lang="en-US" smtClean="0"/>
+              <a:rPr lang="en-US"/>
               <a:t>Click to edit Master text styles</a:t>
             </a:r>
           </a:p>
           <a:p>
             <a:pPr lvl="1"/>
             <a:r>
-              <a:rPr lang="en-US" smtClean="0"/>
+              <a:rPr lang="en-US"/>
               <a:t>Second level</a:t>
             </a:r>
           </a:p>
           <a:p>
             <a:pPr lvl="2"/>
             <a:r>
-              <a:rPr lang="en-US" smtClean="0"/>
+              <a:rPr lang="en-US"/>
               <a:t>Third level</a:t>
             </a:r>
           </a:p>
           <a:p>
             <a:pPr lvl="3"/>
             <a:r>
-              <a:rPr lang="en-US" smtClean="0"/>
+              <a:rPr lang="en-US"/>
               <a:t>Fourth level</a:t>
             </a:r>
           </a:p>
           <a:p>
             <a:pPr lvl="4"/>
             <a:r>
-              <a:rPr lang="en-US" smtClean="0"/>
+              <a:rPr lang="en-US"/>
               <a:t>Fifth level</a:t>
             </a:r>
-            <a:endParaRPr lang="en-US"/>
           </a:p>
         </p:txBody>
       </p:sp>
@@ -465,7 +477,7 @@
           <a:p>
             <a:fld id="{5BCAD085-E8A6-8845-BD4E-CB4CCA059FC4}" type="datetimeFigureOut">
               <a:rPr lang="en-US" smtClean="0"/>
-              <a:t>1/27/13</a:t>
+              <a:t>8/30/2026</a:t>
             </a:fld>
             <a:endParaRPr lang="en-US"/>
           </a:p>
@@ -564,10 +576,9 @@
           <a:lstStyle/>
           <a:p>
             <a:r>
-              <a:rPr lang="en-US" smtClean="0"/>
+              <a:rPr lang="en-US"/>
               <a:t>Click to edit Master title style</a:t>
             </a:r>
-            <a:endParaRPr lang="en-US"/>
           </a:p>
         </p:txBody>
       </p:sp>
@@ -593,38 +604,37 @@
           <a:p>
             <a:pPr lvl="0"/>
             <a:r>
-              <a:rPr lang="en-US" smtClean="0"/>
+              <a:rPr lang="en-US"/>
               <a:t>Click to edit Master text styles</a:t>
             </a:r>
           </a:p>
           <a:p>
             <a:pPr lvl="1"/>
             <a:r>
-              <a:rPr lang="en-US" smtClean="0"/>
+              <a:rPr lang="en-US"/>
               <a:t>Second level</a:t>
             </a:r>
           </a:p>
           <a:p>
             <a:pPr lvl="2"/>
             <a:r>
-              <a:rPr lang="en-US" smtClean="0"/>
+              <a:rPr lang="en-US"/>
               <a:t>Third level</a:t>
             </a:r>
           </a:p>
           <a:p>
             <a:pPr lvl="3"/>
             <a:r>
-              <a:rPr lang="en-US" smtClean="0"/>
+              <a:rPr lang="en-US"/>
               <a:t>Fourth level</a:t>
             </a:r>
           </a:p>
           <a:p>
             <a:pPr lvl="4"/>
             <a:r>
-              <a:rPr lang="en-US" smtClean="0"/>
+              <a:rPr lang="en-US"/>
               <a:t>Fifth level</a:t>
             </a:r>
-            <a:endParaRPr lang="en-US"/>
           </a:p>
         </p:txBody>
       </p:sp>
@@ -645,7 +655,7 @@
           <a:p>
             <a:fld id="{5BCAD085-E8A6-8845-BD4E-CB4CCA059FC4}" type="datetimeFigureOut">
               <a:rPr lang="en-US" smtClean="0"/>
-              <a:t>1/27/13</a:t>
+              <a:t>8/30/2026</a:t>
             </a:fld>
             <a:endParaRPr lang="en-US"/>
           </a:p>
@@ -739,10 +749,9 @@
           <a:lstStyle/>
           <a:p>
             <a:r>
-              <a:rPr lang="en-US" smtClean="0"/>
+              <a:rPr lang="en-US"/>
               <a:t>Click to edit Master title style</a:t>
             </a:r>
-            <a:endParaRPr lang="en-US"/>
           </a:p>
         </p:txBody>
       </p:sp>
@@ -763,38 +772,37 @@
           <a:p>
             <a:pPr lvl="0"/>
             <a:r>
-              <a:rPr lang="en-US" smtClean="0"/>
+              <a:rPr lang="en-US"/>
               <a:t>Click to edit Master text styles</a:t>
             </a:r>
           </a:p>
           <a:p>
             <a:pPr lvl="1"/>
             <a:r>
-              <a:rPr lang="en-US" smtClean="0"/>
+              <a:rPr lang="en-US"/>
               <a:t>Second level</a:t>
             </a:r>
           </a:p>
           <a:p>
             <a:pPr lvl="2"/>
             <a:r>
-              <a:rPr lang="en-US" smtClean="0"/>
+              <a:rPr lang="en-US"/>
               <a:t>Third level</a:t>
             </a:r>
           </a:p>
           <a:p>
             <a:pPr lvl="3"/>
             <a:r>
-              <a:rPr lang="en-US" smtClean="0"/>
+              <a:rPr lang="en-US"/>
               <a:t>Fourth level</a:t>
             </a:r>
           </a:p>
           <a:p>
             <a:pPr lvl="4"/>
             <a:r>
-              <a:rPr lang="en-US" smtClean="0"/>
+              <a:rPr lang="en-US"/>
               <a:t>Fifth level</a:t>
             </a:r>
-            <a:endParaRPr lang="en-US"/>
           </a:p>
         </p:txBody>
       </p:sp>
@@ -815,7 +823,7 @@
           <a:p>
             <a:fld id="{5BCAD085-E8A6-8845-BD4E-CB4CCA059FC4}" type="datetimeFigureOut">
               <a:rPr lang="en-US" smtClean="0"/>
-              <a:t>1/27/13</a:t>
+              <a:t>8/30/2026</a:t>
             </a:fld>
             <a:endParaRPr lang="en-US"/>
           </a:p>
@@ -918,10 +926,9 @@
           </a:lstStyle>
           <a:p>
             <a:r>
-              <a:rPr lang="en-US" smtClean="0"/>
+              <a:rPr lang="en-US"/>
               <a:t>Click to edit Master title style</a:t>
             </a:r>
-            <a:endParaRPr lang="en-US"/>
           </a:p>
         </p:txBody>
       </p:sp>
@@ -1038,7 +1045,7 @@
           <a:p>
             <a:pPr lvl="0"/>
             <a:r>
-              <a:rPr lang="en-US" smtClean="0"/>
+              <a:rPr lang="en-US"/>
               <a:t>Click to edit Master text styles</a:t>
             </a:r>
           </a:p>
@@ -1061,7 +1068,7 @@
           <a:p>
             <a:fld id="{5BCAD085-E8A6-8845-BD4E-CB4CCA059FC4}" type="datetimeFigureOut">
               <a:rPr lang="en-US" smtClean="0"/>
-              <a:t>1/27/13</a:t>
+              <a:t>8/30/2026</a:t>
             </a:fld>
             <a:endParaRPr lang="en-US"/>
           </a:p>
@@ -1155,10 +1162,9 @@
           <a:lstStyle/>
           <a:p>
             <a:r>
-              <a:rPr lang="en-US" smtClean="0"/>
+              <a:rPr lang="en-US"/>
               <a:t>Click to edit Master title style</a:t>
             </a:r>
-            <a:endParaRPr lang="en-US"/>
           </a:p>
         </p:txBody>
       </p:sp>
@@ -1212,38 +1218,37 @@
           <a:p>
             <a:pPr lvl="0"/>
             <a:r>
-              <a:rPr lang="en-US" smtClean="0"/>
+              <a:rPr lang="en-US"/>
               <a:t>Click to edit Master text styles</a:t>
             </a:r>
           </a:p>
           <a:p>
             <a:pPr lvl="1"/>
             <a:r>
-              <a:rPr lang="en-US" smtClean="0"/>
+              <a:rPr lang="en-US"/>
               <a:t>Second level</a:t>
             </a:r>
           </a:p>
           <a:p>
             <a:pPr lvl="2"/>
             <a:r>
-              <a:rPr lang="en-US" smtClean="0"/>
+              <a:rPr lang="en-US"/>
               <a:t>Third level</a:t>
             </a:r>
           </a:p>
           <a:p>
             <a:pPr lvl="3"/>
             <a:r>
-              <a:rPr lang="en-US" smtClean="0"/>
+              <a:rPr lang="en-US"/>
               <a:t>Fourth level</a:t>
             </a:r>
           </a:p>
           <a:p>
             <a:pPr lvl="4"/>
             <a:r>
-              <a:rPr lang="en-US" smtClean="0"/>
+              <a:rPr lang="en-US"/>
               <a:t>Fifth level</a:t>
             </a:r>
-            <a:endParaRPr lang="en-US"/>
           </a:p>
         </p:txBody>
       </p:sp>
@@ -1297,38 +1302,37 @@
           <a:p>
             <a:pPr lvl="0"/>
             <a:r>
-              <a:rPr lang="en-US" smtClean="0"/>
+              <a:rPr lang="en-US"/>
               <a:t>Click to edit Master text styles</a:t>
             </a:r>
           </a:p>
           <a:p>
             <a:pPr lvl="1"/>
             <a:r>
-              <a:rPr lang="en-US" smtClean="0"/>
+              <a:rPr lang="en-US"/>
               <a:t>Second level</a:t>
             </a:r>
           </a:p>
           <a:p>
             <a:pPr lvl="2"/>
             <a:r>
-              <a:rPr lang="en-US" smtClean="0"/>
+              <a:rPr lang="en-US"/>
               <a:t>Third level</a:t>
             </a:r>
           </a:p>
           <a:p>
             <a:pPr lvl="3"/>
             <a:r>
-              <a:rPr lang="en-US" smtClean="0"/>
+              <a:rPr lang="en-US"/>
               <a:t>Fourth level</a:t>
             </a:r>
           </a:p>
           <a:p>
             <a:pPr lvl="4"/>
             <a:r>
-              <a:rPr lang="en-US" smtClean="0"/>
+              <a:rPr lang="en-US"/>
               <a:t>Fifth level</a:t>
             </a:r>
-            <a:endParaRPr lang="en-US"/>
           </a:p>
         </p:txBody>
       </p:sp>
@@ -1349,7 +1353,7 @@
           <a:p>
             <a:fld id="{5BCAD085-E8A6-8845-BD4E-CB4CCA059FC4}" type="datetimeFigureOut">
               <a:rPr lang="en-US" smtClean="0"/>
-              <a:t>1/27/13</a:t>
+              <a:t>8/30/2026</a:t>
             </a:fld>
             <a:endParaRPr lang="en-US"/>
           </a:p>
@@ -1447,10 +1451,9 @@
           </a:lstStyle>
           <a:p>
             <a:r>
-              <a:rPr lang="en-US" smtClean="0"/>
+              <a:rPr lang="en-US"/>
               <a:t>Click to edit Master title style</a:t>
             </a:r>
-            <a:endParaRPr lang="en-US"/>
           </a:p>
         </p:txBody>
       </p:sp>
@@ -1513,7 +1516,7 @@
           <a:p>
             <a:pPr lvl="0"/>
             <a:r>
-              <a:rPr lang="en-US" smtClean="0"/>
+              <a:rPr lang="en-US"/>
               <a:t>Click to edit Master text styles</a:t>
             </a:r>
           </a:p>
@@ -1569,38 +1572,37 @@
           <a:p>
             <a:pPr lvl="0"/>
             <a:r>
-              <a:rPr lang="en-US" smtClean="0"/>
+              <a:rPr lang="en-US"/>
               <a:t>Click to edit Master text styles</a:t>
             </a:r>
           </a:p>
           <a:p>
             <a:pPr lvl="1"/>
             <a:r>
-              <a:rPr lang="en-US" smtClean="0"/>
+              <a:rPr lang="en-US"/>
               <a:t>Second level</a:t>
             </a:r>
           </a:p>
           <a:p>
             <a:pPr lvl="2"/>
             <a:r>
-              <a:rPr lang="en-US" smtClean="0"/>
+              <a:rPr lang="en-US"/>
               <a:t>Third level</a:t>
             </a:r>
           </a:p>
           <a:p>
             <a:pPr lvl="3"/>
             <a:r>
-              <a:rPr lang="en-US" smtClean="0"/>
+              <a:rPr lang="en-US"/>
               <a:t>Fourth level</a:t>
             </a:r>
           </a:p>
           <a:p>
             <a:pPr lvl="4"/>
             <a:r>
-              <a:rPr lang="en-US" smtClean="0"/>
+              <a:rPr lang="en-US"/>
               <a:t>Fifth level</a:t>
             </a:r>
-            <a:endParaRPr lang="en-US"/>
           </a:p>
         </p:txBody>
       </p:sp>
@@ -1663,7 +1665,7 @@
           <a:p>
             <a:pPr lvl="0"/>
             <a:r>
-              <a:rPr lang="en-US" smtClean="0"/>
+              <a:rPr lang="en-US"/>
               <a:t>Click to edit Master text styles</a:t>
             </a:r>
           </a:p>
@@ -1719,38 +1721,37 @@
           <a:p>
             <a:pPr lvl="0"/>
             <a:r>
-              <a:rPr lang="en-US" smtClean="0"/>
+              <a:rPr lang="en-US"/>
               <a:t>Click to edit Master text styles</a:t>
             </a:r>
           </a:p>
           <a:p>
             <a:pPr lvl="1"/>
             <a:r>
-              <a:rPr lang="en-US" smtClean="0"/>
+              <a:rPr lang="en-US"/>
               <a:t>Second level</a:t>
             </a:r>
           </a:p>
           <a:p>
             <a:pPr lvl="2"/>
             <a:r>
-              <a:rPr lang="en-US" smtClean="0"/>
+              <a:rPr lang="en-US"/>
               <a:t>Third level</a:t>
             </a:r>
           </a:p>
           <a:p>
             <a:pPr lvl="3"/>
             <a:r>
-              <a:rPr lang="en-US" smtClean="0"/>
+              <a:rPr lang="en-US"/>
               <a:t>Fourth level</a:t>
             </a:r>
           </a:p>
           <a:p>
             <a:pPr lvl="4"/>
             <a:r>
-              <a:rPr lang="en-US" smtClean="0"/>
+              <a:rPr lang="en-US"/>
               <a:t>Fifth level</a:t>
             </a:r>
-            <a:endParaRPr lang="en-US"/>
           </a:p>
         </p:txBody>
       </p:sp>
@@ -1771,7 +1772,7 @@
           <a:p>
             <a:fld id="{5BCAD085-E8A6-8845-BD4E-CB4CCA059FC4}" type="datetimeFigureOut">
               <a:rPr lang="en-US" smtClean="0"/>
-              <a:t>1/27/13</a:t>
+              <a:t>8/30/2026</a:t>
             </a:fld>
             <a:endParaRPr lang="en-US"/>
           </a:p>
@@ -1865,10 +1866,9 @@
           <a:lstStyle/>
           <a:p>
             <a:r>
-              <a:rPr lang="en-US" smtClean="0"/>
+              <a:rPr lang="en-US"/>
               <a:t>Click to edit Master title style</a:t>
             </a:r>
-            <a:endParaRPr lang="en-US"/>
           </a:p>
         </p:txBody>
       </p:sp>
@@ -1889,7 +1889,7 @@
           <a:p>
             <a:fld id="{5BCAD085-E8A6-8845-BD4E-CB4CCA059FC4}" type="datetimeFigureOut">
               <a:rPr lang="en-US" smtClean="0"/>
-              <a:t>1/27/13</a:t>
+              <a:t>8/30/2026</a:t>
             </a:fld>
             <a:endParaRPr lang="en-US"/>
           </a:p>
@@ -1984,7 +1984,7 @@
           <a:p>
             <a:fld id="{5BCAD085-E8A6-8845-BD4E-CB4CCA059FC4}" type="datetimeFigureOut">
               <a:rPr lang="en-US" smtClean="0"/>
-              <a:t>1/27/13</a:t>
+              <a:t>8/30/2026</a:t>
             </a:fld>
             <a:endParaRPr lang="en-US"/>
           </a:p>
@@ -2087,10 +2087,9 @@
           </a:lstStyle>
           <a:p>
             <a:r>
-              <a:rPr lang="en-US" smtClean="0"/>
+              <a:rPr lang="en-US"/>
               <a:t>Click to edit Master title style</a:t>
             </a:r>
-            <a:endParaRPr lang="en-US"/>
           </a:p>
         </p:txBody>
       </p:sp>
@@ -2144,38 +2143,37 @@
           <a:p>
             <a:pPr lvl="0"/>
             <a:r>
-              <a:rPr lang="en-US" smtClean="0"/>
+              <a:rPr lang="en-US"/>
               <a:t>Click to edit Master text styles</a:t>
             </a:r>
           </a:p>
           <a:p>
             <a:pPr lvl="1"/>
             <a:r>
-              <a:rPr lang="en-US" smtClean="0"/>
+              <a:rPr lang="en-US"/>
               <a:t>Second level</a:t>
             </a:r>
           </a:p>
           <a:p>
             <a:pPr lvl="2"/>
             <a:r>
-              <a:rPr lang="en-US" smtClean="0"/>
+              <a:rPr lang="en-US"/>
               <a:t>Third level</a:t>
             </a:r>
           </a:p>
           <a:p>
             <a:pPr lvl="3"/>
             <a:r>
-              <a:rPr lang="en-US" smtClean="0"/>
+              <a:rPr lang="en-US"/>
               <a:t>Fourth level</a:t>
             </a:r>
           </a:p>
           <a:p>
             <a:pPr lvl="4"/>
             <a:r>
-              <a:rPr lang="en-US" smtClean="0"/>
+              <a:rPr lang="en-US"/>
               <a:t>Fifth level</a:t>
             </a:r>
-            <a:endParaRPr lang="en-US"/>
           </a:p>
         </p:txBody>
       </p:sp>
@@ -2238,7 +2236,7 @@
           <a:p>
             <a:pPr lvl="0"/>
             <a:r>
-              <a:rPr lang="en-US" smtClean="0"/>
+              <a:rPr lang="en-US"/>
               <a:t>Click to edit Master text styles</a:t>
             </a:r>
           </a:p>
@@ -2261,7 +2259,7 @@
           <a:p>
             <a:fld id="{5BCAD085-E8A6-8845-BD4E-CB4CCA059FC4}" type="datetimeFigureOut">
               <a:rPr lang="en-US" smtClean="0"/>
-              <a:t>1/27/13</a:t>
+              <a:t>8/30/2026</a:t>
             </a:fld>
             <a:endParaRPr lang="en-US"/>
           </a:p>
@@ -2364,10 +2362,9 @@
           </a:lstStyle>
           <a:p>
             <a:r>
-              <a:rPr lang="en-US" smtClean="0"/>
+              <a:rPr lang="en-US"/>
               <a:t>Click to edit Master title style</a:t>
             </a:r>
-            <a:endParaRPr lang="en-US"/>
           </a:p>
         </p:txBody>
       </p:sp>
@@ -2491,7 +2488,7 @@
           <a:p>
             <a:pPr lvl="0"/>
             <a:r>
-              <a:rPr lang="en-US" smtClean="0"/>
+              <a:rPr lang="en-US"/>
               <a:t>Click to edit Master text styles</a:t>
             </a:r>
           </a:p>
@@ -2514,7 +2511,7 @@
           <a:p>
             <a:fld id="{5BCAD085-E8A6-8845-BD4E-CB4CCA059FC4}" type="datetimeFigureOut">
               <a:rPr lang="en-US" smtClean="0"/>
-              <a:t>1/27/13</a:t>
+              <a:t>8/30/2026</a:t>
             </a:fld>
             <a:endParaRPr lang="en-US"/>
           </a:p>
@@ -2623,10 +2620,9 @@
           <a:lstStyle/>
           <a:p>
             <a:r>
-              <a:rPr lang="en-US" smtClean="0"/>
+              <a:rPr lang="en-US"/>
               <a:t>Click to edit Master title style</a:t>
             </a:r>
-            <a:endParaRPr lang="en-US"/>
           </a:p>
         </p:txBody>
       </p:sp>
@@ -2657,38 +2653,37 @@
           <a:p>
             <a:pPr lvl="0"/>
             <a:r>
-              <a:rPr lang="en-US" smtClean="0"/>
+              <a:rPr lang="en-US"/>
               <a:t>Click to edit Master text styles</a:t>
             </a:r>
           </a:p>
           <a:p>
             <a:pPr lvl="1"/>
             <a:r>
-              <a:rPr lang="en-US" smtClean="0"/>
+              <a:rPr lang="en-US"/>
               <a:t>Second level</a:t>
             </a:r>
           </a:p>
           <a:p>
             <a:pPr lvl="2"/>
             <a:r>
-              <a:rPr lang="en-US" smtClean="0"/>
+              <a:rPr lang="en-US"/>
               <a:t>Third level</a:t>
             </a:r>
           </a:p>
           <a:p>
             <a:pPr lvl="3"/>
             <a:r>
-              <a:rPr lang="en-US" smtClean="0"/>
+              <a:rPr lang="en-US"/>
               <a:t>Fourth level</a:t>
             </a:r>
           </a:p>
           <a:p>
             <a:pPr lvl="4"/>
             <a:r>
-              <a:rPr lang="en-US" smtClean="0"/>
+              <a:rPr lang="en-US"/>
               <a:t>Fifth level</a:t>
             </a:r>
-            <a:endParaRPr lang="en-US"/>
           </a:p>
         </p:txBody>
       </p:sp>
@@ -2727,7 +2722,7 @@
           <a:p>
             <a:fld id="{5BCAD085-E8A6-8845-BD4E-CB4CCA059FC4}" type="datetimeFigureOut">
               <a:rPr lang="en-US" smtClean="0"/>
-              <a:t>1/27/13</a:t>
+              <a:t>8/30/2026</a:t>
             </a:fld>
             <a:endParaRPr lang="en-US"/>
           </a:p>
@@ -3086,7 +3081,7 @@
 </file>
 
 <file path=ppt/slides/slide1.xml><?xml version="1.0" encoding="utf-8"?>
-<p:sld xmlns:a="http://schemas.openxmlformats.org/drawingml/2006/main" xmlns:p="http://schemas.openxmlformats.org/presentationml/2006/main" xmlns:r="http://schemas.openxmlformats.org/officeDocument/2006/relationships">
+<p:sld xmlns:a="http://schemas.openxmlformats.org/drawingml/2006/main" xmlns:r="http://schemas.openxmlformats.org/officeDocument/2006/relationships" xmlns:p="http://schemas.openxmlformats.org/presentationml/2006/main">
   <p:cSld>
     <p:bg>
       <p:bgPr>
@@ -3102,7 +3097,14 @@
         <p:cNvGrpSpPr/>
         <p:nvPr/>
       </p:nvGrpSpPr>
-      <p:grpSpPr/>
+      <p:grpSpPr>
+        <a:xfrm>
+          <a:off x="0" y="0"/>
+          <a:ext cx="0" cy="0"/>
+          <a:chOff x="0" y="0"/>
+          <a:chExt cx="0" cy="0"/>
+        </a:xfrm>
+      </p:grpSpPr>
       <p:sp>
         <p:nvSpPr>
           <p:cNvPr id="2" name="TextBox 1"/>
@@ -3200,7 +3202,7 @@
 </file>
 
 <file path=ppt/slides/slide2.xml><?xml version="1.0" encoding="utf-8"?>
-<p:sld xmlns:a="http://schemas.openxmlformats.org/drawingml/2006/main" xmlns:p="http://schemas.openxmlformats.org/presentationml/2006/main" xmlns:r="http://schemas.openxmlformats.org/officeDocument/2006/relationships">
+<p:sld xmlns:a="http://schemas.openxmlformats.org/drawingml/2006/main" xmlns:r="http://schemas.openxmlformats.org/officeDocument/2006/relationships" xmlns:p="http://schemas.openxmlformats.org/presentationml/2006/main">
   <p:cSld>
     <p:bg>
       <p:bgPr>
@@ -3216,7 +3218,14 @@
         <p:cNvGrpSpPr/>
         <p:nvPr/>
       </p:nvGrpSpPr>
-      <p:grpSpPr/>
+      <p:grpSpPr>
+        <a:xfrm>
+          <a:off x="0" y="0"/>
+          <a:ext cx="0" cy="0"/>
+          <a:chOff x="0" y="0"/>
+          <a:chExt cx="0" cy="0"/>
+        </a:xfrm>
+      </p:grpSpPr>
       <p:sp>
         <p:nvSpPr>
           <p:cNvPr id="2" name="TextBox 1"/>
@@ -3226,7 +3235,7 @@
         <p:spPr>
           <a:xfrm>
             <a:off x="731520" y="320040"/>
-            <a:ext cx="10728655" cy="868680"/>
+            <a:ext cx="10728655" cy="600164"/>
           </a:xfrm>
           <a:prstGeom prst="rect">
             <a:avLst/>
@@ -3247,6 +3256,7 @@
               </a:defRPr>
             </a:pPr>
             <a:r>
+              <a:rPr dirty="0"/>
               <a:t>HARMONY — PERSONAL JOURNAL AUDITING WEB APP</a:t>
             </a:r>
           </a:p>
@@ -3259,7 +3269,16 @@
               </a:defRPr>
             </a:pPr>
             <a:r>
-              <a:t>📋 Executive Summary &amp; Codelab Compliance Checklist</a:t>
+              <a:rPr dirty="0"/>
+              <a:t>Executive Summary &amp;</a:t>
+            </a:r>
+            <a:r>
+              <a:rPr lang="en-IN" dirty="0"/>
+              <a:t> </a:t>
+            </a:r>
+            <a:r>
+              <a:rPr dirty="0"/>
+              <a:t>Compliance Checklist</a:t>
             </a:r>
           </a:p>
         </p:txBody>
@@ -3270,11 +3289,17 @@
           <p:cNvGraphicFramePr>
             <a:graphicFrameLocks noGrp="1"/>
           </p:cNvGraphicFramePr>
-          <p:nvPr/>
+          <p:nvPr>
+            <p:extLst>
+              <p:ext uri="{D42A27DB-BD31-4B8C-83A1-F6EECF244321}">
+                <p14:modId xmlns:p14="http://schemas.microsoft.com/office/powerpoint/2010/main" val="486286326"/>
+              </p:ext>
+            </p:extLst>
+          </p:nvPr>
         </p:nvGraphicFramePr>
         <p:xfrm>
-          <a:off x="731520" y="1234440"/>
-          <a:ext cx="10728655" cy="5120640"/>
+          <a:off x="731521" y="1234440"/>
+          <a:ext cx="8832610" cy="5120640"/>
         </p:xfrm>
         <a:graphic>
           <a:graphicData uri="http://schemas.openxmlformats.org/drawingml/2006/table">
@@ -3283,9 +3308,27 @@
                 <a:tableStyleId>{5C22544A-7EE6-4342-B048-85BDC9FD1C3A}</a:tableStyleId>
               </a:tblPr>
               <a:tblGrid>
-                <a:gridCol w="3108960"/>
-                <a:gridCol w="6248095"/>
-                <a:gridCol w="1371600"/>
+                <a:gridCol w="2559522">
+                  <a:extLst>
+                    <a:ext uri="{9D8B030D-6E8A-4147-A177-3AD203B41FA5}">
+                      <a16:colId xmlns:a16="http://schemas.microsoft.com/office/drawing/2014/main" val="20000"/>
+                    </a:ext>
+                  </a:extLst>
+                </a:gridCol>
+                <a:gridCol w="5143887">
+                  <a:extLst>
+                    <a:ext uri="{9D8B030D-6E8A-4147-A177-3AD203B41FA5}">
+                      <a16:colId xmlns:a16="http://schemas.microsoft.com/office/drawing/2014/main" val="20001"/>
+                    </a:ext>
+                  </a:extLst>
+                </a:gridCol>
+                <a:gridCol w="1129201">
+                  <a:extLst>
+                    <a:ext uri="{9D8B030D-6E8A-4147-A177-3AD203B41FA5}">
+                      <a16:colId xmlns:a16="http://schemas.microsoft.com/office/drawing/2014/main" val="20002"/>
+                    </a:ext>
+                  </a:extLst>
+                </a:gridCol>
               </a:tblGrid>
               <a:tr h="568960">
                 <a:tc>
@@ -3294,7 +3337,7 @@
                     <a:lstStyle/>
                     <a:p>
                       <a:pPr>
-                        <a:defRPr b="1" sz="1200">
+                        <a:defRPr sz="1200" b="1">
                           <a:solidFill>
                             <a:srgbClr val="FFFFFF"/>
                           </a:solidFill>
@@ -3317,7 +3360,7 @@
                     <a:lstStyle/>
                     <a:p>
                       <a:pPr>
-                        <a:defRPr b="1" sz="1200">
+                        <a:defRPr sz="1200" b="1">
                           <a:solidFill>
                             <a:srgbClr val="FFFFFF"/>
                           </a:solidFill>
@@ -3340,7 +3383,7 @@
                     <a:lstStyle/>
                     <a:p>
                       <a:pPr>
-                        <a:defRPr b="1" sz="1200">
+                        <a:defRPr sz="1200" b="1">
                           <a:solidFill>
                             <a:srgbClr val="FFFFFF"/>
                           </a:solidFill>
@@ -3357,6 +3400,11 @@
                     </a:solidFill>
                   </a:tcPr>
                 </a:tc>
+                <a:extLst>
+                  <a:ext uri="{0D108BD9-81ED-4DB2-BD59-A6C34878D82A}">
+                    <a16:rowId xmlns:a16="http://schemas.microsoft.com/office/drawing/2014/main" val="10000"/>
+                  </a:ext>
+                </a:extLst>
               </a:tr>
               <a:tr h="568960">
                 <a:tc>
@@ -3418,7 +3466,12 @@
                         </a:defRPr>
                       </a:pPr>
                       <a:r>
-                        <a:t>✅ Completed</a:t>
+                        <a:rPr lang="en-IN" dirty="0"/>
+                        <a:t> </a:t>
+                      </a:r>
+                      <a:r>
+                        <a:rPr dirty="0"/>
+                        <a:t>Completed</a:t>
                       </a:r>
                     </a:p>
                   </a:txBody>
@@ -3428,6 +3481,11 @@
                     </a:solidFill>
                   </a:tcPr>
                 </a:tc>
+                <a:extLst>
+                  <a:ext uri="{0D108BD9-81ED-4DB2-BD59-A6C34878D82A}">
+                    <a16:rowId xmlns:a16="http://schemas.microsoft.com/office/drawing/2014/main" val="10001"/>
+                  </a:ext>
+                </a:extLst>
               </a:tr>
               <a:tr h="568960">
                 <a:tc>
@@ -3489,7 +3547,12 @@
                         </a:defRPr>
                       </a:pPr>
                       <a:r>
-                        <a:t>✅ Completed</a:t>
+                        <a:rPr lang="en-IN" dirty="0"/>
+                        <a:t> </a:t>
+                      </a:r>
+                      <a:r>
+                        <a:rPr dirty="0"/>
+                        <a:t>Completed</a:t>
                       </a:r>
                     </a:p>
                   </a:txBody>
@@ -3499,6 +3562,11 @@
                     </a:solidFill>
                   </a:tcPr>
                 </a:tc>
+                <a:extLst>
+                  <a:ext uri="{0D108BD9-81ED-4DB2-BD59-A6C34878D82A}">
+                    <a16:rowId xmlns:a16="http://schemas.microsoft.com/office/drawing/2014/main" val="10002"/>
+                  </a:ext>
+                </a:extLst>
               </a:tr>
               <a:tr h="568960">
                 <a:tc>
@@ -3560,7 +3628,8 @@
                         </a:defRPr>
                       </a:pPr>
                       <a:r>
-                        <a:t>✅ Completed</a:t>
+                        <a:rPr dirty="0"/>
+                        <a:t> Completed</a:t>
                       </a:r>
                     </a:p>
                   </a:txBody>
@@ -3570,6 +3639,11 @@
                     </a:solidFill>
                   </a:tcPr>
                 </a:tc>
+                <a:extLst>
+                  <a:ext uri="{0D108BD9-81ED-4DB2-BD59-A6C34878D82A}">
+                    <a16:rowId xmlns:a16="http://schemas.microsoft.com/office/drawing/2014/main" val="10003"/>
+                  </a:ext>
+                </a:extLst>
               </a:tr>
               <a:tr h="568960">
                 <a:tc>
@@ -3631,7 +3705,8 @@
                         </a:defRPr>
                       </a:pPr>
                       <a:r>
-                        <a:t>✅ Completed</a:t>
+                        <a:rPr dirty="0"/>
+                        <a:t> Completed</a:t>
                       </a:r>
                     </a:p>
                   </a:txBody>
@@ -3641,6 +3716,11 @@
                     </a:solidFill>
                   </a:tcPr>
                 </a:tc>
+                <a:extLst>
+                  <a:ext uri="{0D108BD9-81ED-4DB2-BD59-A6C34878D82A}">
+                    <a16:rowId xmlns:a16="http://schemas.microsoft.com/office/drawing/2014/main" val="10004"/>
+                  </a:ext>
+                </a:extLst>
               </a:tr>
               <a:tr h="568960">
                 <a:tc>
@@ -3702,7 +3782,8 @@
                         </a:defRPr>
                       </a:pPr>
                       <a:r>
-                        <a:t>✅ Completed</a:t>
+                        <a:rPr dirty="0"/>
+                        <a:t> Completed</a:t>
                       </a:r>
                     </a:p>
                   </a:txBody>
@@ -3712,6 +3793,11 @@
                     </a:solidFill>
                   </a:tcPr>
                 </a:tc>
+                <a:extLst>
+                  <a:ext uri="{0D108BD9-81ED-4DB2-BD59-A6C34878D82A}">
+                    <a16:rowId xmlns:a16="http://schemas.microsoft.com/office/drawing/2014/main" val="10005"/>
+                  </a:ext>
+                </a:extLst>
               </a:tr>
               <a:tr h="568960">
                 <a:tc>
@@ -3773,7 +3859,8 @@
                         </a:defRPr>
                       </a:pPr>
                       <a:r>
-                        <a:t>✅ Completed</a:t>
+                        <a:rPr dirty="0"/>
+                        <a:t> Completed</a:t>
                       </a:r>
                     </a:p>
                   </a:txBody>
@@ -3783,6 +3870,11 @@
                     </a:solidFill>
                   </a:tcPr>
                 </a:tc>
+                <a:extLst>
+                  <a:ext uri="{0D108BD9-81ED-4DB2-BD59-A6C34878D82A}">
+                    <a16:rowId xmlns:a16="http://schemas.microsoft.com/office/drawing/2014/main" val="10006"/>
+                  </a:ext>
+                </a:extLst>
               </a:tr>
               <a:tr h="568960">
                 <a:tc>
@@ -3844,7 +3936,8 @@
                         </a:defRPr>
                       </a:pPr>
                       <a:r>
-                        <a:t>✅ Completed</a:t>
+                        <a:rPr dirty="0"/>
+                        <a:t> Completed</a:t>
                       </a:r>
                     </a:p>
                   </a:txBody>
@@ -3854,6 +3947,11 @@
                     </a:solidFill>
                   </a:tcPr>
                 </a:tc>
+                <a:extLst>
+                  <a:ext uri="{0D108BD9-81ED-4DB2-BD59-A6C34878D82A}">
+                    <a16:rowId xmlns:a16="http://schemas.microsoft.com/office/drawing/2014/main" val="10007"/>
+                  </a:ext>
+                </a:extLst>
               </a:tr>
               <a:tr h="568960">
                 <a:tc>
@@ -3915,7 +4013,8 @@
                         </a:defRPr>
                       </a:pPr>
                       <a:r>
-                        <a:t>✅ Completed</a:t>
+                        <a:rPr dirty="0"/>
+                        <a:t> Completed</a:t>
                       </a:r>
                     </a:p>
                   </a:txBody>
@@ -3925,6 +4024,11 @@
                     </a:solidFill>
                   </a:tcPr>
                 </a:tc>
+                <a:extLst>
+                  <a:ext uri="{0D108BD9-81ED-4DB2-BD59-A6C34878D82A}">
+                    <a16:rowId xmlns:a16="http://schemas.microsoft.com/office/drawing/2014/main" val="10008"/>
+                  </a:ext>
+                </a:extLst>
               </a:tr>
             </a:tbl>
           </a:graphicData>
@@ -3939,7 +4043,7 @@
 </file>
 
 <file path=ppt/slides/slide3.xml><?xml version="1.0" encoding="utf-8"?>
-<p:sld xmlns:a="http://schemas.openxmlformats.org/drawingml/2006/main" xmlns:p="http://schemas.openxmlformats.org/presentationml/2006/main" xmlns:r="http://schemas.openxmlformats.org/officeDocument/2006/relationships">
+<p:sld xmlns:a="http://schemas.openxmlformats.org/drawingml/2006/main" xmlns:r="http://schemas.openxmlformats.org/officeDocument/2006/relationships" xmlns:p="http://schemas.openxmlformats.org/presentationml/2006/main">
   <p:cSld>
     <p:bg>
       <p:bgPr>
@@ -3955,7 +4059,14 @@
         <p:cNvGrpSpPr/>
         <p:nvPr/>
       </p:nvGrpSpPr>
-      <p:grpSpPr/>
+      <p:grpSpPr>
+        <a:xfrm>
+          <a:off x="0" y="0"/>
+          <a:ext cx="0" cy="0"/>
+          <a:chOff x="0" y="0"/>
+          <a:chExt cx="0" cy="0"/>
+        </a:xfrm>
+      </p:grpSpPr>
       <p:sp>
         <p:nvSpPr>
           <p:cNvPr id="2" name="TextBox 1"/>
@@ -4019,8 +4130,8 @@
         </p:blipFill>
         <p:spPr>
           <a:xfrm>
-            <a:off x="731520" y="1234440"/>
-            <a:ext cx="10728655" cy="5212080"/>
+            <a:off x="731521" y="1234440"/>
+            <a:ext cx="8807896" cy="5212080"/>
           </a:xfrm>
           <a:prstGeom prst="rect">
             <a:avLst/>
@@ -4036,7 +4147,7 @@
 </file>
 
 <file path=ppt/slides/slide4.xml><?xml version="1.0" encoding="utf-8"?>
-<p:sld xmlns:a="http://schemas.openxmlformats.org/drawingml/2006/main" xmlns:p="http://schemas.openxmlformats.org/presentationml/2006/main" xmlns:r="http://schemas.openxmlformats.org/officeDocument/2006/relationships">
+<p:sld xmlns:a="http://schemas.openxmlformats.org/drawingml/2006/main" xmlns:r="http://schemas.openxmlformats.org/officeDocument/2006/relationships" xmlns:p="http://schemas.openxmlformats.org/presentationml/2006/main">
   <p:cSld>
     <p:bg>
       <p:bgPr>
@@ -4052,7 +4163,14 @@
         <p:cNvGrpSpPr/>
         <p:nvPr/>
       </p:nvGrpSpPr>
-      <p:grpSpPr/>
+      <p:grpSpPr>
+        <a:xfrm>
+          <a:off x="0" y="0"/>
+          <a:ext cx="0" cy="0"/>
+          <a:chOff x="0" y="0"/>
+          <a:chExt cx="0" cy="0"/>
+        </a:xfrm>
+      </p:grpSpPr>
       <p:sp>
         <p:nvSpPr>
           <p:cNvPr id="2" name="TextBox 1"/>
@@ -4062,7 +4180,7 @@
         <p:spPr>
           <a:xfrm>
             <a:off x="731520" y="320040"/>
-            <a:ext cx="10728655" cy="868680"/>
+            <a:ext cx="10728655" cy="600164"/>
           </a:xfrm>
           <a:prstGeom prst="rect">
             <a:avLst/>
@@ -4083,6 +4201,7 @@
               </a:defRPr>
             </a:pPr>
             <a:r>
+              <a:rPr dirty="0"/>
               <a:t>HARMONY — PERSONAL JOURNAL AUDITING WEB APP</a:t>
             </a:r>
           </a:p>
@@ -4095,7 +4214,8 @@
               </a:defRPr>
             </a:pPr>
             <a:r>
-              <a:t>🔒 Security Verification Matrix &amp; Zero-Trust Bounds</a:t>
+              <a:rPr dirty="0"/>
+              <a:t>Security Verification Matrix &amp; Zero-Trust Bounds</a:t>
             </a:r>
           </a:p>
         </p:txBody>
@@ -4106,11 +4226,17 @@
           <p:cNvGraphicFramePr>
             <a:graphicFrameLocks noGrp="1"/>
           </p:cNvGraphicFramePr>
-          <p:nvPr/>
+          <p:nvPr>
+            <p:extLst>
+              <p:ext uri="{D42A27DB-BD31-4B8C-83A1-F6EECF244321}">
+                <p14:modId xmlns:p14="http://schemas.microsoft.com/office/powerpoint/2010/main" val="2445680641"/>
+              </p:ext>
+            </p:extLst>
+          </p:nvPr>
         </p:nvGraphicFramePr>
         <p:xfrm>
           <a:off x="731520" y="1280160"/>
-          <a:ext cx="10728655" cy="4937760"/>
+          <a:ext cx="9483399" cy="4937760"/>
         </p:xfrm>
         <a:graphic>
           <a:graphicData uri="http://schemas.openxmlformats.org/drawingml/2006/table">
@@ -4119,10 +4245,34 @@
                 <a:tableStyleId>{5C22544A-7EE6-4342-B048-85BDC9FD1C3A}</a:tableStyleId>
               </a:tblPr>
               <a:tblGrid>
-                <a:gridCol w="2560320"/>
-                <a:gridCol w="4114800"/>
-                <a:gridCol w="2956255"/>
-                <a:gridCol w="1097280"/>
+                <a:gridCol w="2263148">
+                  <a:extLst>
+                    <a:ext uri="{9D8B030D-6E8A-4147-A177-3AD203B41FA5}">
+                      <a16:colId xmlns:a16="http://schemas.microsoft.com/office/drawing/2014/main" val="20000"/>
+                    </a:ext>
+                  </a:extLst>
+                </a:gridCol>
+                <a:gridCol w="3637202">
+                  <a:extLst>
+                    <a:ext uri="{9D8B030D-6E8A-4147-A177-3AD203B41FA5}">
+                      <a16:colId xmlns:a16="http://schemas.microsoft.com/office/drawing/2014/main" val="20001"/>
+                    </a:ext>
+                  </a:extLst>
+                </a:gridCol>
+                <a:gridCol w="2613128">
+                  <a:extLst>
+                    <a:ext uri="{9D8B030D-6E8A-4147-A177-3AD203B41FA5}">
+                      <a16:colId xmlns:a16="http://schemas.microsoft.com/office/drawing/2014/main" val="20002"/>
+                    </a:ext>
+                  </a:extLst>
+                </a:gridCol>
+                <a:gridCol w="969921">
+                  <a:extLst>
+                    <a:ext uri="{9D8B030D-6E8A-4147-A177-3AD203B41FA5}">
+                      <a16:colId xmlns:a16="http://schemas.microsoft.com/office/drawing/2014/main" val="20003"/>
+                    </a:ext>
+                  </a:extLst>
+                </a:gridCol>
               </a:tblGrid>
               <a:tr h="822960">
                 <a:tc>
@@ -4131,7 +4281,7 @@
                     <a:lstStyle/>
                     <a:p>
                       <a:pPr>
-                        <a:defRPr b="1" sz="1200">
+                        <a:defRPr sz="1200" b="1">
                           <a:solidFill>
                             <a:srgbClr val="FFFFFF"/>
                           </a:solidFill>
@@ -4154,7 +4304,7 @@
                     <a:lstStyle/>
                     <a:p>
                       <a:pPr>
-                        <a:defRPr b="1" sz="1200">
+                        <a:defRPr sz="1200" b="1">
                           <a:solidFill>
                             <a:srgbClr val="FFFFFF"/>
                           </a:solidFill>
@@ -4177,7 +4327,7 @@
                     <a:lstStyle/>
                     <a:p>
                       <a:pPr>
-                        <a:defRPr b="1" sz="1200">
+                        <a:defRPr sz="1200" b="1">
                           <a:solidFill>
                             <a:srgbClr val="FFFFFF"/>
                           </a:solidFill>
@@ -4200,7 +4350,7 @@
                     <a:lstStyle/>
                     <a:p>
                       <a:pPr>
-                        <a:defRPr b="1" sz="1200">
+                        <a:defRPr sz="1200" b="1">
                           <a:solidFill>
                             <a:srgbClr val="FFFFFF"/>
                           </a:solidFill>
@@ -4217,6 +4367,11 @@
                     </a:solidFill>
                   </a:tcPr>
                 </a:tc>
+                <a:extLst>
+                  <a:ext uri="{0D108BD9-81ED-4DB2-BD59-A6C34878D82A}">
+                    <a16:rowId xmlns:a16="http://schemas.microsoft.com/office/drawing/2014/main" val="10000"/>
+                  </a:ext>
+                </a:extLst>
               </a:tr>
               <a:tr h="822960">
                 <a:tc>
@@ -4301,7 +4456,12 @@
                         </a:defRPr>
                       </a:pPr>
                       <a:r>
-                        <a:t>✅ Passed</a:t>
+                        <a:rPr lang="en-IN" dirty="0"/>
+                        <a:t> </a:t>
+                      </a:r>
+                      <a:r>
+                        <a:rPr dirty="0"/>
+                        <a:t>Passed</a:t>
                       </a:r>
                     </a:p>
                   </a:txBody>
@@ -4311,6 +4471,11 @@
                     </a:solidFill>
                   </a:tcPr>
                 </a:tc>
+                <a:extLst>
+                  <a:ext uri="{0D108BD9-81ED-4DB2-BD59-A6C34878D82A}">
+                    <a16:rowId xmlns:a16="http://schemas.microsoft.com/office/drawing/2014/main" val="10001"/>
+                  </a:ext>
+                </a:extLst>
               </a:tr>
               <a:tr h="822960">
                 <a:tc>
@@ -4395,7 +4560,8 @@
                         </a:defRPr>
                       </a:pPr>
                       <a:r>
-                        <a:t>✅ Passed</a:t>
+                        <a:rPr dirty="0"/>
+                        <a:t> Passed</a:t>
                       </a:r>
                     </a:p>
                   </a:txBody>
@@ -4405,6 +4571,11 @@
                     </a:solidFill>
                   </a:tcPr>
                 </a:tc>
+                <a:extLst>
+                  <a:ext uri="{0D108BD9-81ED-4DB2-BD59-A6C34878D82A}">
+                    <a16:rowId xmlns:a16="http://schemas.microsoft.com/office/drawing/2014/main" val="10002"/>
+                  </a:ext>
+                </a:extLst>
               </a:tr>
               <a:tr h="822960">
                 <a:tc>
@@ -4489,7 +4660,8 @@
                         </a:defRPr>
                       </a:pPr>
                       <a:r>
-                        <a:t>✅ Passed</a:t>
+                        <a:rPr dirty="0"/>
+                        <a:t> Passed</a:t>
                       </a:r>
                     </a:p>
                   </a:txBody>
@@ -4499,6 +4671,11 @@
                     </a:solidFill>
                   </a:tcPr>
                 </a:tc>
+                <a:extLst>
+                  <a:ext uri="{0D108BD9-81ED-4DB2-BD59-A6C34878D82A}">
+                    <a16:rowId xmlns:a16="http://schemas.microsoft.com/office/drawing/2014/main" val="10003"/>
+                  </a:ext>
+                </a:extLst>
               </a:tr>
               <a:tr h="822960">
                 <a:tc>
@@ -4583,7 +4760,8 @@
                         </a:defRPr>
                       </a:pPr>
                       <a:r>
-                        <a:t>✅ Passed</a:t>
+                        <a:rPr dirty="0"/>
+                        <a:t> Passed</a:t>
                       </a:r>
                     </a:p>
                   </a:txBody>
@@ -4593,6 +4771,11 @@
                     </a:solidFill>
                   </a:tcPr>
                 </a:tc>
+                <a:extLst>
+                  <a:ext uri="{0D108BD9-81ED-4DB2-BD59-A6C34878D82A}">
+                    <a16:rowId xmlns:a16="http://schemas.microsoft.com/office/drawing/2014/main" val="10004"/>
+                  </a:ext>
+                </a:extLst>
               </a:tr>
               <a:tr h="822960">
                 <a:tc>
@@ -4677,7 +4860,8 @@
                         </a:defRPr>
                       </a:pPr>
                       <a:r>
-                        <a:t>✅ Passed</a:t>
+                        <a:rPr dirty="0"/>
+                        <a:t> Passed</a:t>
                       </a:r>
                     </a:p>
                   </a:txBody>
@@ -4687,6 +4871,11 @@
                     </a:solidFill>
                   </a:tcPr>
                 </a:tc>
+                <a:extLst>
+                  <a:ext uri="{0D108BD9-81ED-4DB2-BD59-A6C34878D82A}">
+                    <a16:rowId xmlns:a16="http://schemas.microsoft.com/office/drawing/2014/main" val="10005"/>
+                  </a:ext>
+                </a:extLst>
               </a:tr>
             </a:tbl>
           </a:graphicData>
@@ -4701,7 +4890,7 @@
 </file>
 
 <file path=ppt/slides/slide5.xml><?xml version="1.0" encoding="utf-8"?>
-<p:sld xmlns:a="http://schemas.openxmlformats.org/drawingml/2006/main" xmlns:p="http://schemas.openxmlformats.org/presentationml/2006/main" xmlns:r="http://schemas.openxmlformats.org/officeDocument/2006/relationships">
+<p:sld xmlns:a="http://schemas.openxmlformats.org/drawingml/2006/main" xmlns:r="http://schemas.openxmlformats.org/officeDocument/2006/relationships" xmlns:p="http://schemas.openxmlformats.org/presentationml/2006/main">
   <p:cSld>
     <p:bg>
       <p:bgPr>
@@ -4717,7 +4906,14 @@
         <p:cNvGrpSpPr/>
         <p:nvPr/>
       </p:nvGrpSpPr>
-      <p:grpSpPr/>
+      <p:grpSpPr>
+        <a:xfrm>
+          <a:off x="0" y="0"/>
+          <a:ext cx="0" cy="0"/>
+          <a:chOff x="0" y="0"/>
+          <a:chExt cx="0" cy="0"/>
+        </a:xfrm>
+      </p:grpSpPr>
       <p:sp>
         <p:nvSpPr>
           <p:cNvPr id="2" name="TextBox 1"/>
@@ -4727,7 +4923,7 @@
         <p:spPr>
           <a:xfrm>
             <a:off x="731520" y="320040"/>
-            <a:ext cx="10728655" cy="868680"/>
+            <a:ext cx="10728655" cy="600164"/>
           </a:xfrm>
           <a:prstGeom prst="rect">
             <a:avLst/>
@@ -4748,6 +4944,7 @@
               </a:defRPr>
             </a:pPr>
             <a:r>
+              <a:rPr dirty="0"/>
               <a:t>HARMONY — PERSONAL JOURNAL AUDITING WEB APP</a:t>
             </a:r>
           </a:p>
@@ -4760,7 +4957,8 @@
               </a:defRPr>
             </a:pPr>
             <a:r>
-              <a:t>💬 Intelligent Reflection Chat &amp; Conversational Auditing Engine</a:t>
+              <a:rPr dirty="0"/>
+              <a:t>Intelligent Reflection Chat &amp; Conversational Auditing Engine</a:t>
             </a:r>
           </a:p>
         </p:txBody>
@@ -4782,7 +4980,7 @@
         <p:spPr>
           <a:xfrm>
             <a:off x="731520" y="1234440"/>
-            <a:ext cx="10728655" cy="5212080"/>
+            <a:ext cx="8791421" cy="5212080"/>
           </a:xfrm>
           <a:prstGeom prst="rect">
             <a:avLst/>
@@ -4798,7 +4996,7 @@
 </file>
 
 <file path=ppt/slides/slide6.xml><?xml version="1.0" encoding="utf-8"?>
-<p:sld xmlns:a="http://schemas.openxmlformats.org/drawingml/2006/main" xmlns:p="http://schemas.openxmlformats.org/presentationml/2006/main" xmlns:r="http://schemas.openxmlformats.org/officeDocument/2006/relationships">
+<p:sld xmlns:a="http://schemas.openxmlformats.org/drawingml/2006/main" xmlns:r="http://schemas.openxmlformats.org/officeDocument/2006/relationships" xmlns:p="http://schemas.openxmlformats.org/presentationml/2006/main">
   <p:cSld>
     <p:bg>
       <p:bgPr>
@@ -4814,7 +5012,14 @@
         <p:cNvGrpSpPr/>
         <p:nvPr/>
       </p:nvGrpSpPr>
-      <p:grpSpPr/>
+      <p:grpSpPr>
+        <a:xfrm>
+          <a:off x="0" y="0"/>
+          <a:ext cx="0" cy="0"/>
+          <a:chOff x="0" y="0"/>
+          <a:chExt cx="0" cy="0"/>
+        </a:xfrm>
+      </p:grpSpPr>
       <p:sp>
         <p:nvSpPr>
           <p:cNvPr id="2" name="TextBox 1"/>
@@ -4824,7 +5029,7 @@
         <p:spPr>
           <a:xfrm>
             <a:off x="731520" y="320040"/>
-            <a:ext cx="10728655" cy="868680"/>
+            <a:ext cx="10728655" cy="600164"/>
           </a:xfrm>
           <a:prstGeom prst="rect">
             <a:avLst/>
@@ -4845,6 +5050,7 @@
               </a:defRPr>
             </a:pPr>
             <a:r>
+              <a:rPr dirty="0"/>
               <a:t>HARMONY — PERSONAL JOURNAL AUDITING WEB APP</a:t>
             </a:r>
           </a:p>
@@ -4857,7 +5063,8 @@
               </a:defRPr>
             </a:pPr>
             <a:r>
-              <a:t>📈 Visual Progress Analytics &amp; Mood Chart Audits</a:t>
+              <a:rPr dirty="0"/>
+              <a:t>Visual Progress Analytics &amp; Mood Chart Audits</a:t>
             </a:r>
           </a:p>
         </p:txBody>
@@ -4879,7 +5086,7 @@
         <p:spPr>
           <a:xfrm>
             <a:off x="731520" y="1234440"/>
-            <a:ext cx="10728655" cy="5212080"/>
+            <a:ext cx="8865561" cy="5212080"/>
           </a:xfrm>
           <a:prstGeom prst="rect">
             <a:avLst/>
@@ -4895,7 +5102,7 @@
 </file>
 
 <file path=ppt/slides/slide7.xml><?xml version="1.0" encoding="utf-8"?>
-<p:sld xmlns:a="http://schemas.openxmlformats.org/drawingml/2006/main" xmlns:p="http://schemas.openxmlformats.org/presentationml/2006/main" xmlns:r="http://schemas.openxmlformats.org/officeDocument/2006/relationships">
+<p:sld xmlns:a="http://schemas.openxmlformats.org/drawingml/2006/main" xmlns:r="http://schemas.openxmlformats.org/officeDocument/2006/relationships" xmlns:p="http://schemas.openxmlformats.org/presentationml/2006/main">
   <p:cSld>
     <p:bg>
       <p:bgPr>
@@ -4911,7 +5118,14 @@
         <p:cNvGrpSpPr/>
         <p:nvPr/>
       </p:nvGrpSpPr>
-      <p:grpSpPr/>
+      <p:grpSpPr>
+        <a:xfrm>
+          <a:off x="0" y="0"/>
+          <a:ext cx="0" cy="0"/>
+          <a:chOff x="0" y="0"/>
+          <a:chExt cx="0" cy="0"/>
+        </a:xfrm>
+      </p:grpSpPr>
       <p:sp>
         <p:nvSpPr>
           <p:cNvPr id="2" name="TextBox 1"/>
@@ -4921,7 +5135,7 @@
         <p:spPr>
           <a:xfrm>
             <a:off x="731520" y="320040"/>
-            <a:ext cx="10728655" cy="868680"/>
+            <a:ext cx="10728655" cy="600164"/>
           </a:xfrm>
           <a:prstGeom prst="rect">
             <a:avLst/>
@@ -4942,6 +5156,7 @@
               </a:defRPr>
             </a:pPr>
             <a:r>
+              <a:rPr dirty="0"/>
               <a:t>HARMONY — PERSONAL JOURNAL AUDITING WEB APP</a:t>
             </a:r>
           </a:p>
@@ -4954,7 +5169,8 @@
               </a:defRPr>
             </a:pPr>
             <a:r>
-              <a:t>✅ Automated Action Items &amp; Unified To-Do Sync</a:t>
+              <a:rPr dirty="0"/>
+              <a:t>Automated Action Items &amp; Unified To-Do Sync</a:t>
             </a:r>
           </a:p>
         </p:txBody>
@@ -4976,7 +5192,7 @@
         <p:spPr>
           <a:xfrm>
             <a:off x="731520" y="1234440"/>
-            <a:ext cx="10728655" cy="5212080"/>
+            <a:ext cx="8783183" cy="5212080"/>
           </a:xfrm>
           <a:prstGeom prst="rect">
             <a:avLst/>
@@ -4992,7 +5208,7 @@
 </file>
 
 <file path=ppt/slides/slide8.xml><?xml version="1.0" encoding="utf-8"?>
-<p:sld xmlns:a="http://schemas.openxmlformats.org/drawingml/2006/main" xmlns:p="http://schemas.openxmlformats.org/presentationml/2006/main" xmlns:r="http://schemas.openxmlformats.org/officeDocument/2006/relationships">
+<p:sld xmlns:a="http://schemas.openxmlformats.org/drawingml/2006/main" xmlns:r="http://schemas.openxmlformats.org/officeDocument/2006/relationships" xmlns:p="http://schemas.openxmlformats.org/presentationml/2006/main">
   <p:cSld>
     <p:bg>
       <p:bgPr>
@@ -5008,7 +5224,14 @@
         <p:cNvGrpSpPr/>
         <p:nvPr/>
       </p:nvGrpSpPr>
-      <p:grpSpPr/>
+      <p:grpSpPr>
+        <a:xfrm>
+          <a:off x="0" y="0"/>
+          <a:ext cx="0" cy="0"/>
+          <a:chOff x="0" y="0"/>
+          <a:chExt cx="0" cy="0"/>
+        </a:xfrm>
+      </p:grpSpPr>
       <p:sp>
         <p:nvSpPr>
           <p:cNvPr id="2" name="TextBox 1"/>
@@ -5018,7 +5241,7 @@
         <p:spPr>
           <a:xfrm>
             <a:off x="731520" y="320040"/>
-            <a:ext cx="10728655" cy="868680"/>
+            <a:ext cx="10728655" cy="600164"/>
           </a:xfrm>
           <a:prstGeom prst="rect">
             <a:avLst/>
@@ -5039,6 +5262,7 @@
               </a:defRPr>
             </a:pPr>
             <a:r>
+              <a:rPr dirty="0"/>
               <a:t>HARMONY — PERSONAL JOURNAL AUDITING WEB APP</a:t>
             </a:r>
           </a:p>
@@ -5051,8 +5275,14 @@
               </a:defRPr>
             </a:pPr>
             <a:r>
-              <a:t>📅 Daily Reflection Logs &amp; Interactive Calendar Auditing Workspace</a:t>
-            </a:r>
+              <a:rPr dirty="0"/>
+              <a:t>Daily Reflection Logs &amp; Interactive </a:t>
+            </a:r>
+            <a:r>
+              <a:rPr lang="en-IN" dirty="0"/>
+              <a:t>Signup Pages</a:t>
+            </a:r>
+            <a:endParaRPr dirty="0"/>
           </a:p>
         </p:txBody>
       </p:sp>
@@ -5073,7 +5303,7 @@
         <p:spPr>
           <a:xfrm>
             <a:off x="731520" y="1234440"/>
-            <a:ext cx="10728655" cy="5212080"/>
+            <a:ext cx="8766707" cy="5212080"/>
           </a:xfrm>
           <a:prstGeom prst="rect">
             <a:avLst/>

</xml_diff>